<commit_message>
figures 4 paper updated
</commit_message>
<xml_diff>
--- a/Figures/figures4paper.pptx
+++ b/Figures/figures4paper.pptx
@@ -6,10 +6,12 @@
   </p:sldMasterIdLst>
   <p:sldIdLst>
     <p:sldId id="261" r:id="rId2"/>
-    <p:sldId id="257" r:id="rId3"/>
-    <p:sldId id="258" r:id="rId4"/>
-    <p:sldId id="259" r:id="rId5"/>
-    <p:sldId id="260" r:id="rId6"/>
+    <p:sldId id="262" r:id="rId3"/>
+    <p:sldId id="257" r:id="rId4"/>
+    <p:sldId id="258" r:id="rId5"/>
+    <p:sldId id="259" r:id="rId6"/>
+    <p:sldId id="260" r:id="rId7"/>
+    <p:sldId id="263" r:id="rId8"/>
   </p:sldIdLst>
   <p:sldSz cx="9144000" cy="6858000" type="screen4x3"/>
   <p:notesSz cx="6858000" cy="9144000"/>
@@ -108,7 +110,201 @@
       </a:defRPr>
     </a:lvl9pPr>
   </p:defaultTextStyle>
+  <p:extLst>
+    <p:ext uri="{EFAFB233-063F-42B5-8137-9DF3F51BA10A}">
+      <p15:sldGuideLst xmlns:p15="http://schemas.microsoft.com/office/powerpoint/2012/main"/>
+    </p:ext>
+  </p:extLst>
 </p:presentation>
+</file>
+
+<file path=ppt/ink/ink1.xml><?xml version="1.0" encoding="utf-8"?>
+<inkml:ink xmlns:inkml="http://www.w3.org/2003/InkML">
+  <inkml:definitions>
+    <inkml:context xml:id="ctx0">
+      <inkml:inkSource xml:id="inkSrc0">
+        <inkml:traceFormat>
+          <inkml:channel name="X" type="integer" min="-2.14748E9" max="2.14748E9" units="cm"/>
+          <inkml:channel name="Y" type="integer" min="-2.14748E9" max="2.14748E9" units="cm"/>
+          <inkml:channel name="F" type="integer" max="32767" units="dev"/>
+        </inkml:traceFormat>
+        <inkml:channelProperties>
+          <inkml:channelProperty channel="X" name="resolution" value="1000" units="1/cm"/>
+          <inkml:channelProperty channel="Y" name="resolution" value="1000" units="1/cm"/>
+          <inkml:channelProperty channel="F" name="resolution" value="0" units="1/dev"/>
+        </inkml:channelProperties>
+      </inkml:inkSource>
+      <inkml:timestamp xml:id="ts0" timeString="2025-04-02T19:59:16.618"/>
+    </inkml:context>
+    <inkml:brush xml:id="br0">
+      <inkml:brushProperty name="width" value="0.035" units="cm"/>
+      <inkml:brushProperty name="height" value="0.035" units="cm"/>
+    </inkml:brush>
+  </inkml:definitions>
+  <inkml:trace contextRef="#ctx0" brushRef="#br0">0 1 24575,'7'0'0,"-1"0"0,2 0 0,1 0 0,1 0 0,1 0 0,-1 0 0,-2 0 0,1 0 0,-1 0 0,-1 3 0,0 0 0,-1 2 0,0-1 0,0 0 0,-1 0 0,0 0 0,0 0 0,0-2 0,-1 0 0,0-1 0,1 0 0,0 0 0,0 1 0,0 0 0,-1-1 0,1 0 0,-1 0 0,0-1 0,1 1 0,-1 0 0,2 0 0,1-1 0,0 1 0,1-1 0,-1 0 0,-1 0 0,0 1 0,-1-1 0,1 2 0,-1-1 0,0 0 0,0 1 0,0-1 0,1 0 0,1 1 0,0 0 0,0 0 0,-1 0 0,-2 0 0,0-2 0,0 1 0,0 0 0,1-1 0,0 1 0,0 0 0,-1 0 0,0-1 0,0 1 0,0-1 0,1 0 0,0 0 0,3 0 0,0 0 0,1 0 0,0 0 0,-1 0 0,-2 1 0,0 0 0,0-1 0,0 0 0,1 0 0,0 0 0,0 0 0,-1 0 0,-1 0 0,0 0 0,0 0 0,0 0 0,-1 0 0,-1 0 0,-1 0 0,1 0 0,-1 0 0,1 0 0,1 0 0,-1 0 0,1 0 0,-1 0 0,0 0 0,0 0 0,0 0 0,-1 0 0,1 0 0,0 0 0,1 0 0,1 1 0,0 0 0,1 1 0,-1-1 0,0 1 0,-2 0 0,0-1 0,-1 0 0,0 0 0,0-1 0,-1 0 0,0 0 0</inkml:trace>
+</inkml:ink>
+</file>
+
+<file path=ppt/ink/ink2.xml><?xml version="1.0" encoding="utf-8"?>
+<inkml:ink xmlns:inkml="http://www.w3.org/2003/InkML">
+  <inkml:definitions>
+    <inkml:context xml:id="ctx0">
+      <inkml:inkSource xml:id="inkSrc0">
+        <inkml:traceFormat>
+          <inkml:channel name="X" type="integer" min="-2.14748E9" max="2.14748E9" units="cm"/>
+          <inkml:channel name="Y" type="integer" min="-2.14748E9" max="2.14748E9" units="cm"/>
+          <inkml:channel name="F" type="integer" max="32767" units="dev"/>
+        </inkml:traceFormat>
+        <inkml:channelProperties>
+          <inkml:channelProperty channel="X" name="resolution" value="1000" units="1/cm"/>
+          <inkml:channelProperty channel="Y" name="resolution" value="1000" units="1/cm"/>
+          <inkml:channelProperty channel="F" name="resolution" value="0" units="1/dev"/>
+        </inkml:channelProperties>
+      </inkml:inkSource>
+      <inkml:timestamp xml:id="ts0" timeString="2025-04-02T19:59:19.284"/>
+    </inkml:context>
+    <inkml:brush xml:id="br0">
+      <inkml:brushProperty name="width" value="0.035" units="cm"/>
+      <inkml:brushProperty name="height" value="0.035" units="cm"/>
+    </inkml:brush>
+  </inkml:definitions>
+  <inkml:trace contextRef="#ctx0" brushRef="#br0">0 1 24575,'4'0'0,"1"0"0,-1 0 0,0 0 0,2 0 0,0 0 0,2 0 0,-1 0 0,0 0 0,-2 1 0,1 1 0,1 1 0,-1-1 0,0 1 0,0-1 0,0-1 0,1 2 0,1-1 0,0 1 0,1 0 0,0 1 0,0-1 0,-1 1 0,-1-2 0,-3 1 0,0 0 0,0 0 0,-2 1 0,2-1 0,0 1 0,0-1 0,2-1 0,-1-1 0,0 0 0,0 0 0,0 0 0,1-1 0,0 0 0,1 0 0,1 0 0,-1 0 0,1 1 0,0 1 0,0 0 0,0-1 0,-1 1 0,-1 0 0,-1-1 0,0 0 0,0 1 0,1 0 0,-1-1 0,0 0 0,0 0 0,-1 0 0,0 0 0,1 1 0,1 0 0,2 2 0,3 0 0,1 1 0,0 1 0,0-1 0,-2 0 0,-2 0 0,-1-1 0,-1-2 0,-1 0 0,1-1 0,0 1 0,1 0 0,2 0 0,-1-1 0,-1 1 0,0 0 0,-1 0 0,-2 0 0,0-1 0,-2 0 0,0-1 0,0 1 0,0 0 0,0 1 0,-1-2 0,0 1 0</inkml:trace>
+</inkml:ink>
+</file>
+
+<file path=ppt/ink/ink3.xml><?xml version="1.0" encoding="utf-8"?>
+<inkml:ink xmlns:inkml="http://www.w3.org/2003/InkML">
+  <inkml:definitions>
+    <inkml:context xml:id="ctx0">
+      <inkml:inkSource xml:id="inkSrc0">
+        <inkml:traceFormat>
+          <inkml:channel name="X" type="integer" min="-2.14748E9" max="2.14748E9" units="cm"/>
+          <inkml:channel name="Y" type="integer" min="-2.14748E9" max="2.14748E9" units="cm"/>
+          <inkml:channel name="F" type="integer" max="32767" units="dev"/>
+        </inkml:traceFormat>
+        <inkml:channelProperties>
+          <inkml:channelProperty channel="X" name="resolution" value="1000" units="1/cm"/>
+          <inkml:channelProperty channel="Y" name="resolution" value="1000" units="1/cm"/>
+          <inkml:channelProperty channel="F" name="resolution" value="0" units="1/dev"/>
+        </inkml:channelProperties>
+      </inkml:inkSource>
+      <inkml:timestamp xml:id="ts0" timeString="2025-04-02T19:59:21.684"/>
+    </inkml:context>
+    <inkml:brush xml:id="br0">
+      <inkml:brushProperty name="width" value="0.035" units="cm"/>
+      <inkml:brushProperty name="height" value="0.035" units="cm"/>
+    </inkml:brush>
+  </inkml:definitions>
+  <inkml:trace contextRef="#ctx0" brushRef="#br0">0 1 24575,'1'7'0,"1"-1"0,0-2 0,1-2 0,0 1 0,2 0 0,1 0 0,0 0 0,-1-1 0,1 1 0,-1-2 0,0 1 0,1 0 0,-1 1 0,0-1 0,1 1 0,0-1 0,2 1 0,-1 0 0,-1 0 0,-1 0 0,0 0 0,0 0 0,1 1 0,-1 1 0,2 1 0,1 2 0,2 1 0,1 2 0,0 0 0,-1-2 0,0 0 0,0 0 0,-1-1 0,1 1 0,-2-2 0,-1 0 0,-1-2 0,0-1 0,0 0 0,2 0 0,1 0 0,3 1 0,2 1 0,2 0 0,-1 0 0,1-1 0,-2-2 0,-3 0 0,-2-1 0,-3 0 0,-1 1 0,0-1 0,-1 1 0,1 0 0,0 1 0,2 0 0,0 1 0,0 0 0,-1-2 0,-1 0 0,-1 0 0,-1 0 0,-1 0 0,0 0 0,0 1 0,0-1 0,1 0 0,-1 1 0,1-1 0,-1 1 0,1 1 0,-1 0 0,1 0 0,-1-1 0,-1-1 0,-1-1 0,1 1 0,-1 0 0,1-1 0,0 0 0</inkml:trace>
+</inkml:ink>
+</file>
+
+<file path=ppt/ink/ink4.xml><?xml version="1.0" encoding="utf-8"?>
+<inkml:ink xmlns:inkml="http://www.w3.org/2003/InkML">
+  <inkml:definitions>
+    <inkml:context xml:id="ctx0">
+      <inkml:inkSource xml:id="inkSrc0">
+        <inkml:traceFormat>
+          <inkml:channel name="X" type="integer" min="-2.14748E9" max="2.14748E9" units="cm"/>
+          <inkml:channel name="Y" type="integer" min="-2.14748E9" max="2.14748E9" units="cm"/>
+          <inkml:channel name="F" type="integer" max="32767" units="dev"/>
+        </inkml:traceFormat>
+        <inkml:channelProperties>
+          <inkml:channelProperty channel="X" name="resolution" value="1000" units="1/cm"/>
+          <inkml:channelProperty channel="Y" name="resolution" value="1000" units="1/cm"/>
+          <inkml:channelProperty channel="F" name="resolution" value="0" units="1/dev"/>
+        </inkml:channelProperties>
+      </inkml:inkSource>
+      <inkml:timestamp xml:id="ts0" timeString="2025-04-02T19:59:23.901"/>
+    </inkml:context>
+    <inkml:brush xml:id="br0">
+      <inkml:brushProperty name="width" value="0.035" units="cm"/>
+      <inkml:brushProperty name="height" value="0.035" units="cm"/>
+    </inkml:brush>
+  </inkml:definitions>
+  <inkml:trace contextRef="#ctx0" brushRef="#br0">0 1 24575,'4'2'0,"0"2"0,0 1 0,-1 0 0,0-1 0,1 0 0,2 1 0,0 2 0,2 2 0,-1 0 0,0-2 0,-1 0 0,-1-2 0,0 1 0,1-2 0,0 0 0,0-2 0,1 0 0,0 0 0,0-1 0,0 0 0,-1 0 0,1 1 0,-1 1 0,0-1 0,0 1 0,-1-1 0,0 2 0,1 1 0,1 2 0,1 1 0,-1 0 0,0 0 0,-1-1 0,1-1 0,-1 1 0,0 1 0,1-1 0,-1 0 0,0 0 0,0-1 0,-1 1 0,1 0 0,-1 0 0,0-1 0,-1-1 0,0 1 0,2 3 0,2 1 0,3 2 0,0 0 0,0-1 0,-3-3 0,-2-2 0,-2-2 0,-2-1 0,0-1 0,-1 0 0,0 0 0,0-1 0</inkml:trace>
+</inkml:ink>
+</file>
+
+<file path=ppt/ink/ink5.xml><?xml version="1.0" encoding="utf-8"?>
+<inkml:ink xmlns:inkml="http://www.w3.org/2003/InkML">
+  <inkml:definitions>
+    <inkml:context xml:id="ctx0">
+      <inkml:inkSource xml:id="inkSrc0">
+        <inkml:traceFormat>
+          <inkml:channel name="X" type="integer" min="-2.14748E9" max="2.14748E9" units="cm"/>
+          <inkml:channel name="Y" type="integer" min="-2.14748E9" max="2.14748E9" units="cm"/>
+          <inkml:channel name="F" type="integer" max="32767" units="dev"/>
+        </inkml:traceFormat>
+        <inkml:channelProperties>
+          <inkml:channelProperty channel="X" name="resolution" value="1000" units="1/cm"/>
+          <inkml:channelProperty channel="Y" name="resolution" value="1000" units="1/cm"/>
+          <inkml:channelProperty channel="F" name="resolution" value="0" units="1/dev"/>
+        </inkml:channelProperties>
+      </inkml:inkSource>
+      <inkml:timestamp xml:id="ts0" timeString="2025-04-02T19:59:42.418"/>
+    </inkml:context>
+    <inkml:brush xml:id="br0">
+      <inkml:brushProperty name="width" value="0.035" units="cm"/>
+      <inkml:brushProperty name="height" value="0.035" units="cm"/>
+    </inkml:brush>
+  </inkml:definitions>
+  <inkml:trace contextRef="#ctx0" brushRef="#br0">0 1 24575,'4'0'0,"1"2"0,0 1 0,0 2 0,0 0 0,0 1 0,0 0 0,-1 1 0,1 0 0,0 1 0,-1-1 0,0-2 0,0-1 0,0-2 0,0 0 0,0-1 0,0 0 0,1 1 0,-1 0 0,2 2 0,-1 1 0,1 1 0,0-1 0,-2 0 0,0-2 0,-1 0 0,-1 0 0,1-1 0,-1-1 0,0 1 0,-1-1 0,0 1 0,0-1 0,0 1 0,-1-1 0,1-1 0</inkml:trace>
+</inkml:ink>
+</file>
+
+<file path=ppt/ink/ink6.xml><?xml version="1.0" encoding="utf-8"?>
+<inkml:ink xmlns:inkml="http://www.w3.org/2003/InkML">
+  <inkml:definitions>
+    <inkml:context xml:id="ctx0">
+      <inkml:inkSource xml:id="inkSrc0">
+        <inkml:traceFormat>
+          <inkml:channel name="X" type="integer" min="-2.14748E9" max="2.14748E9" units="cm"/>
+          <inkml:channel name="Y" type="integer" min="-2.14748E9" max="2.14748E9" units="cm"/>
+          <inkml:channel name="F" type="integer" max="32767" units="dev"/>
+        </inkml:traceFormat>
+        <inkml:channelProperties>
+          <inkml:channelProperty channel="X" name="resolution" value="1000" units="1/cm"/>
+          <inkml:channelProperty channel="Y" name="resolution" value="1000" units="1/cm"/>
+          <inkml:channelProperty channel="F" name="resolution" value="0" units="1/dev"/>
+        </inkml:channelProperties>
+      </inkml:inkSource>
+      <inkml:timestamp xml:id="ts0" timeString="2025-04-02T19:59:45.134"/>
+    </inkml:context>
+    <inkml:brush xml:id="br0">
+      <inkml:brushProperty name="width" value="0.035" units="cm"/>
+      <inkml:brushProperty name="height" value="0.035" units="cm"/>
+    </inkml:brush>
+  </inkml:definitions>
+  <inkml:trace contextRef="#ctx0" brushRef="#br0">1 1 24575,'0'0'0</inkml:trace>
+</inkml:ink>
+</file>
+
+<file path=ppt/ink/ink7.xml><?xml version="1.0" encoding="utf-8"?>
+<inkml:ink xmlns:inkml="http://www.w3.org/2003/InkML">
+  <inkml:definitions>
+    <inkml:context xml:id="ctx0">
+      <inkml:inkSource xml:id="inkSrc0">
+        <inkml:traceFormat>
+          <inkml:channel name="X" type="integer" min="-2.14748E9" max="2.14748E9" units="cm"/>
+          <inkml:channel name="Y" type="integer" min="-2.14748E9" max="2.14748E9" units="cm"/>
+          <inkml:channel name="F" type="integer" max="32767" units="dev"/>
+        </inkml:traceFormat>
+        <inkml:channelProperties>
+          <inkml:channelProperty channel="X" name="resolution" value="1000" units="1/cm"/>
+          <inkml:channelProperty channel="Y" name="resolution" value="1000" units="1/cm"/>
+          <inkml:channelProperty channel="F" name="resolution" value="0" units="1/dev"/>
+        </inkml:channelProperties>
+      </inkml:inkSource>
+      <inkml:timestamp xml:id="ts0" timeString="2025-04-02T19:59:49.268"/>
+    </inkml:context>
+    <inkml:brush xml:id="br0">
+      <inkml:brushProperty name="width" value="0.035" units="cm"/>
+      <inkml:brushProperty name="height" value="0.035" units="cm"/>
+    </inkml:brush>
+  </inkml:definitions>
+  <inkml:trace contextRef="#ctx0" brushRef="#br0">1 0 24575,'0'0'0</inkml:trace>
+</inkml:ink>
 </file>
 
 <file path=ppt/slideLayouts/slideLayout1.xml><?xml version="1.0" encoding="utf-8"?>
@@ -242,7 +438,7 @@
           <a:p>
             <a:fld id="{C3621C54-5E9E-8444-959D-3C3EF7C0B317}" type="datetimeFigureOut">
               <a:rPr lang="en-US" smtClean="0"/>
-              <a:t>3/21/25</a:t>
+              <a:t>4/8/25</a:t>
             </a:fld>
             <a:endParaRPr lang="en-US"/>
           </a:p>
@@ -412,7 +608,7 @@
           <a:p>
             <a:fld id="{C3621C54-5E9E-8444-959D-3C3EF7C0B317}" type="datetimeFigureOut">
               <a:rPr lang="en-US" smtClean="0"/>
-              <a:t>3/21/25</a:t>
+              <a:t>4/8/25</a:t>
             </a:fld>
             <a:endParaRPr lang="en-US"/>
           </a:p>
@@ -592,7 +788,7 @@
           <a:p>
             <a:fld id="{C3621C54-5E9E-8444-959D-3C3EF7C0B317}" type="datetimeFigureOut">
               <a:rPr lang="en-US" smtClean="0"/>
-              <a:t>3/21/25</a:t>
+              <a:t>4/8/25</a:t>
             </a:fld>
             <a:endParaRPr lang="en-US"/>
           </a:p>
@@ -762,7 +958,7 @@
           <a:p>
             <a:fld id="{C3621C54-5E9E-8444-959D-3C3EF7C0B317}" type="datetimeFigureOut">
               <a:rPr lang="en-US" smtClean="0"/>
-              <a:t>3/21/25</a:t>
+              <a:t>4/8/25</a:t>
             </a:fld>
             <a:endParaRPr lang="en-US"/>
           </a:p>
@@ -1008,7 +1204,7 @@
           <a:p>
             <a:fld id="{C3621C54-5E9E-8444-959D-3C3EF7C0B317}" type="datetimeFigureOut">
               <a:rPr lang="en-US" smtClean="0"/>
-              <a:t>3/21/25</a:t>
+              <a:t>4/8/25</a:t>
             </a:fld>
             <a:endParaRPr lang="en-US"/>
           </a:p>
@@ -1240,7 +1436,7 @@
           <a:p>
             <a:fld id="{C3621C54-5E9E-8444-959D-3C3EF7C0B317}" type="datetimeFigureOut">
               <a:rPr lang="en-US" smtClean="0"/>
-              <a:t>3/21/25</a:t>
+              <a:t>4/8/25</a:t>
             </a:fld>
             <a:endParaRPr lang="en-US"/>
           </a:p>
@@ -1607,7 +1803,7 @@
           <a:p>
             <a:fld id="{C3621C54-5E9E-8444-959D-3C3EF7C0B317}" type="datetimeFigureOut">
               <a:rPr lang="en-US" smtClean="0"/>
-              <a:t>3/21/25</a:t>
+              <a:t>4/8/25</a:t>
             </a:fld>
             <a:endParaRPr lang="en-US"/>
           </a:p>
@@ -1725,7 +1921,7 @@
           <a:p>
             <a:fld id="{C3621C54-5E9E-8444-959D-3C3EF7C0B317}" type="datetimeFigureOut">
               <a:rPr lang="en-US" smtClean="0"/>
-              <a:t>3/21/25</a:t>
+              <a:t>4/8/25</a:t>
             </a:fld>
             <a:endParaRPr lang="en-US"/>
           </a:p>
@@ -1820,7 +2016,7 @@
           <a:p>
             <a:fld id="{C3621C54-5E9E-8444-959D-3C3EF7C0B317}" type="datetimeFigureOut">
               <a:rPr lang="en-US" smtClean="0"/>
-              <a:t>3/21/25</a:t>
+              <a:t>4/8/25</a:t>
             </a:fld>
             <a:endParaRPr lang="en-US"/>
           </a:p>
@@ -2097,7 +2293,7 @@
           <a:p>
             <a:fld id="{C3621C54-5E9E-8444-959D-3C3EF7C0B317}" type="datetimeFigureOut">
               <a:rPr lang="en-US" smtClean="0"/>
-              <a:t>3/21/25</a:t>
+              <a:t>4/8/25</a:t>
             </a:fld>
             <a:endParaRPr lang="en-US"/>
           </a:p>
@@ -2354,7 +2550,7 @@
           <a:p>
             <a:fld id="{C3621C54-5E9E-8444-959D-3C3EF7C0B317}" type="datetimeFigureOut">
               <a:rPr lang="en-US" smtClean="0"/>
-              <a:t>3/21/25</a:t>
+              <a:t>4/8/25</a:t>
             </a:fld>
             <a:endParaRPr lang="en-US"/>
           </a:p>
@@ -2567,7 +2763,7 @@
           <a:p>
             <a:fld id="{C3621C54-5E9E-8444-959D-3C3EF7C0B317}" type="datetimeFigureOut">
               <a:rPr lang="en-US" smtClean="0"/>
-              <a:t>3/21/25</a:t>
+              <a:t>4/8/25</a:t>
             </a:fld>
             <a:endParaRPr lang="en-US"/>
           </a:p>
@@ -2972,60 +3168,6 @@
           <a:chExt cx="0" cy="0"/>
         </a:xfrm>
       </p:grpSpPr>
-      <p:sp>
-        <p:nvSpPr>
-          <p:cNvPr id="234" name="Rounded Rectangle 233">
-            <a:extLst>
-              <a:ext uri="{FF2B5EF4-FFF2-40B4-BE49-F238E27FC236}">
-                <a16:creationId xmlns:a16="http://schemas.microsoft.com/office/drawing/2014/main" id="{1DFC9129-FDDC-156B-433B-47CBE954A01F}"/>
-              </a:ext>
-            </a:extLst>
-          </p:cNvPr>
-          <p:cNvSpPr/>
-          <p:nvPr/>
-        </p:nvSpPr>
-        <p:spPr>
-          <a:xfrm>
-            <a:off x="3140112" y="4354074"/>
-            <a:ext cx="2331211" cy="2132676"/>
-          </a:xfrm>
-          <a:prstGeom prst="roundRect">
-            <a:avLst>
-              <a:gd name="adj" fmla="val 7222"/>
-            </a:avLst>
-          </a:prstGeom>
-          <a:noFill/>
-          <a:ln>
-            <a:solidFill>
-              <a:schemeClr val="tx1"/>
-            </a:solidFill>
-          </a:ln>
-        </p:spPr>
-        <p:style>
-          <a:lnRef idx="2">
-            <a:schemeClr val="accent1">
-              <a:shade val="15000"/>
-            </a:schemeClr>
-          </a:lnRef>
-          <a:fillRef idx="1">
-            <a:schemeClr val="accent1"/>
-          </a:fillRef>
-          <a:effectRef idx="0">
-            <a:schemeClr val="accent1"/>
-          </a:effectRef>
-          <a:fontRef idx="minor">
-            <a:schemeClr val="lt1"/>
-          </a:fontRef>
-        </p:style>
-        <p:txBody>
-          <a:bodyPr rtlCol="0" anchor="ctr"/>
-          <a:lstStyle/>
-          <a:p>
-            <a:pPr algn="ctr"/>
-            <a:endParaRPr lang="en-US"/>
-          </a:p>
-        </p:txBody>
-      </p:sp>
       <p:pic>
         <p:nvPicPr>
           <p:cNvPr id="128" name="Picture 127">
@@ -3439,8 +3581,8 @@
             </a:fontRef>
           </p:style>
         </p:cxnSp>
-        <mc:AlternateContent xmlns:mc="http://schemas.openxmlformats.org/markup-compatibility/2006">
-          <mc:Choice xmlns:a14="http://schemas.microsoft.com/office/drawing/2010/main" Requires="a14">
+        <mc:AlternateContent xmlns:mc="http://schemas.openxmlformats.org/markup-compatibility/2006" xmlns:a14="http://schemas.microsoft.com/office/drawing/2010/main">
+          <mc:Choice Requires="a14">
             <p:sp>
               <p:nvSpPr>
                 <p:cNvPr id="34" name="TextBox 33">
@@ -3469,6 +3611,7 @@
                 </a:bodyPr>
                 <a:lstStyle/>
                 <a:p>
+                  <a:pPr/>
                   <a14:m>
                     <m:oMathPara xmlns:m="http://schemas.openxmlformats.org/officeDocument/2006/math">
                       <m:oMathParaPr>
@@ -3489,7 +3632,7 @@
               </p:txBody>
             </p:sp>
           </mc:Choice>
-          <mc:Fallback>
+          <mc:Fallback xmlns="">
             <p:sp>
               <p:nvSpPr>
                 <p:cNvPr id="34" name="TextBox 33">
@@ -3534,8 +3677,8 @@
             </p:sp>
           </mc:Fallback>
         </mc:AlternateContent>
-        <mc:AlternateContent xmlns:mc="http://schemas.openxmlformats.org/markup-compatibility/2006">
-          <mc:Choice xmlns:a14="http://schemas.microsoft.com/office/drawing/2010/main" Requires="a14">
+        <mc:AlternateContent xmlns:mc="http://schemas.openxmlformats.org/markup-compatibility/2006" xmlns:a14="http://schemas.microsoft.com/office/drawing/2010/main">
+          <mc:Choice Requires="a14">
             <p:sp>
               <p:nvSpPr>
                 <p:cNvPr id="35" name="TextBox 34">
@@ -3564,6 +3707,7 @@
                 </a:bodyPr>
                 <a:lstStyle/>
                 <a:p>
+                  <a:pPr/>
                   <a14:m>
                     <m:oMathPara xmlns:m="http://schemas.openxmlformats.org/officeDocument/2006/math">
                       <m:oMathParaPr>
@@ -3587,7 +3731,7 @@
               </p:txBody>
             </p:sp>
           </mc:Choice>
-          <mc:Fallback>
+          <mc:Fallback xmlns="">
             <p:sp>
               <p:nvSpPr>
                 <p:cNvPr id="35" name="TextBox 34">
@@ -3729,8 +3873,8 @@
           </a:p>
         </p:txBody>
       </p:sp>
-      <mc:AlternateContent xmlns:mc="http://schemas.openxmlformats.org/markup-compatibility/2006">
-        <mc:Choice xmlns:a14="http://schemas.microsoft.com/office/drawing/2010/main" Requires="a14">
+      <mc:AlternateContent xmlns:mc="http://schemas.openxmlformats.org/markup-compatibility/2006" xmlns:a14="http://schemas.microsoft.com/office/drawing/2010/main">
+        <mc:Choice Requires="a14">
           <p:sp>
             <p:nvSpPr>
               <p:cNvPr id="54" name="TextBox 53">
@@ -3826,7 +3970,7 @@
             </p:txBody>
           </p:sp>
         </mc:Choice>
-        <mc:Fallback>
+        <mc:Fallback xmlns="">
           <p:sp>
             <p:nvSpPr>
               <p:cNvPr id="54" name="TextBox 53">
@@ -3874,8 +4018,8 @@
           </p:sp>
         </mc:Fallback>
       </mc:AlternateContent>
-      <mc:AlternateContent xmlns:mc="http://schemas.openxmlformats.org/markup-compatibility/2006">
-        <mc:Choice xmlns:a14="http://schemas.microsoft.com/office/drawing/2010/main" Requires="a14">
+      <mc:AlternateContent xmlns:mc="http://schemas.openxmlformats.org/markup-compatibility/2006" xmlns:a14="http://schemas.microsoft.com/office/drawing/2010/main">
+        <mc:Choice Requires="a14">
           <p:sp>
             <p:nvSpPr>
               <p:cNvPr id="55" name="TextBox 54">
@@ -4029,7 +4173,7 @@
             </p:txBody>
           </p:sp>
         </mc:Choice>
-        <mc:Fallback>
+        <mc:Fallback xmlns="">
           <p:sp>
             <p:nvSpPr>
               <p:cNvPr id="55" name="TextBox 54">
@@ -4121,8 +4265,8 @@
           </a:p>
         </p:txBody>
       </p:sp>
-      <mc:AlternateContent xmlns:mc="http://schemas.openxmlformats.org/markup-compatibility/2006">
-        <mc:Choice xmlns:a14="http://schemas.microsoft.com/office/drawing/2010/main" Requires="a14">
+      <mc:AlternateContent xmlns:mc="http://schemas.openxmlformats.org/markup-compatibility/2006" xmlns:a14="http://schemas.microsoft.com/office/drawing/2010/main">
+        <mc:Choice Requires="a14">
           <p:sp>
             <p:nvSpPr>
               <p:cNvPr id="60" name="TextBox 59">
@@ -4226,7 +4370,7 @@
             </p:txBody>
           </p:sp>
         </mc:Choice>
-        <mc:Fallback>
+        <mc:Fallback xmlns="">
           <p:sp>
             <p:nvSpPr>
               <p:cNvPr id="60" name="TextBox 59">
@@ -4462,8 +4606,8 @@
             </a:fontRef>
           </p:style>
         </p:cxnSp>
-        <mc:AlternateContent xmlns:mc="http://schemas.openxmlformats.org/markup-compatibility/2006">
-          <mc:Choice xmlns:a14="http://schemas.microsoft.com/office/drawing/2010/main" Requires="a14">
+        <mc:AlternateContent xmlns:mc="http://schemas.openxmlformats.org/markup-compatibility/2006" xmlns:a14="http://schemas.microsoft.com/office/drawing/2010/main">
+          <mc:Choice Requires="a14">
             <p:sp>
               <p:nvSpPr>
                 <p:cNvPr id="75" name="TextBox 74">
@@ -4492,6 +4636,7 @@
                 </a:bodyPr>
                 <a:lstStyle/>
                 <a:p>
+                  <a:pPr/>
                   <a14:m>
                     <m:oMathPara xmlns:m="http://schemas.openxmlformats.org/officeDocument/2006/math">
                       <m:oMathParaPr>
@@ -4524,7 +4669,7 @@
               </p:txBody>
             </p:sp>
           </mc:Choice>
-          <mc:Fallback>
+          <mc:Fallback xmlns="">
             <p:sp>
               <p:nvSpPr>
                 <p:cNvPr id="75" name="TextBox 74">
@@ -4759,7 +4904,7 @@
         </p:nvSpPr>
         <p:spPr>
           <a:xfrm>
-            <a:off x="3304408" y="4173480"/>
+            <a:off x="3301388" y="4743068"/>
             <a:ext cx="2017727" cy="415498"/>
           </a:xfrm>
           <a:prstGeom prst="rect">
@@ -5387,10 +5532,10 @@
                                 </m:sSubPr>
                                 <m:e>
                                   <m:r>
-                                    <a:rPr lang="en-US" sz="1050" i="1">
+                                    <a:rPr lang="en-US" sz="1050" b="0" i="1" smtClean="0">
                                       <a:latin typeface="Cambria Math" panose="02040503050406030204" pitchFamily="18" charset="0"/>
                                     </a:rPr>
-                                    <m:t>𝑝</m:t>
+                                    <m:t>𝑥</m:t>
                                   </m:r>
                                 </m:e>
                                 <m:sub>
@@ -5421,10 +5566,10 @@
                         <m:t>     </m:t>
                       </m:r>
                       <m:r>
-                        <a:rPr lang="en-US" sz="1050" b="1" i="1">
+                        <a:rPr lang="en-US" sz="1050" b="1" i="1" smtClean="0">
                           <a:latin typeface="Cambria Math" panose="02040503050406030204" pitchFamily="18" charset="0"/>
                         </a:rPr>
-                        <m:t>𝒚</m:t>
+                        <m:t>𝜽</m:t>
                       </m:r>
                       <m:r>
                         <a:rPr lang="en-US" sz="1050" i="1">
@@ -5462,7 +5607,7 @@
                                 </m:sSubSupPr>
                                 <m:e>
                                   <m:r>
-                                    <a:rPr lang="en-US" sz="1050" i="1">
+                                    <a:rPr lang="en-US" sz="1050" b="0" i="1" smtClean="0">
                                       <a:latin typeface="Cambria Math" panose="02040503050406030204" pitchFamily="18" charset="0"/>
                                     </a:rPr>
                                     <m:t>𝜃</m:t>
@@ -5675,7 +5820,7 @@
         </p:blipFill>
         <p:spPr>
           <a:xfrm>
-            <a:off x="6079332" y="1170120"/>
+            <a:off x="5946292" y="1172014"/>
             <a:ext cx="1168964" cy="1085466"/>
           </a:xfrm>
           <a:prstGeom prst="rect">
@@ -5773,35 +5918,6 @@
           </a:fontRef>
         </p:style>
       </p:cxnSp>
-      <p:pic>
-        <p:nvPicPr>
-          <p:cNvPr id="217" name="Picture 216">
-            <a:extLst>
-              <a:ext uri="{FF2B5EF4-FFF2-40B4-BE49-F238E27FC236}">
-                <a16:creationId xmlns:a16="http://schemas.microsoft.com/office/drawing/2014/main" id="{07F99232-40DD-194C-334F-B80A16EB2ED0}"/>
-              </a:ext>
-            </a:extLst>
-          </p:cNvPr>
-          <p:cNvPicPr>
-            <a:picLocks noChangeAspect="1"/>
-          </p:cNvPicPr>
-          <p:nvPr/>
-        </p:nvPicPr>
-        <p:blipFill>
-          <a:blip r:embed="rId12"/>
-          <a:srcRect l="22917" t="17041" r="8936" b="6704"/>
-          <a:stretch/>
-        </p:blipFill>
-        <p:spPr>
-          <a:xfrm>
-            <a:off x="3264425" y="4629276"/>
-            <a:ext cx="2109781" cy="1770553"/>
-          </a:xfrm>
-          <a:prstGeom prst="rect">
-            <a:avLst/>
-          </a:prstGeom>
-        </p:spPr>
-      </p:pic>
       <p:cxnSp>
         <p:nvCxnSpPr>
           <p:cNvPr id="219" name="Straight Arrow Connector 218">
@@ -5819,8 +5935,8 @@
         </p:nvCxnSpPr>
         <p:spPr>
           <a:xfrm flipH="1">
-            <a:off x="4313272" y="3901193"/>
-            <a:ext cx="1" cy="272287"/>
+            <a:off x="4310252" y="3901193"/>
+            <a:ext cx="3021" cy="841875"/>
           </a:xfrm>
           <a:prstGeom prst="straightConnector1">
             <a:avLst/>
@@ -5860,7 +5976,7 @@
             </p:nvSpPr>
             <p:spPr>
               <a:xfrm>
-                <a:off x="752450" y="5216687"/>
+                <a:off x="913726" y="4766437"/>
                 <a:ext cx="2023769" cy="415498"/>
               </a:xfrm>
               <a:prstGeom prst="rect">
@@ -5970,14 +6086,14 @@
             </p:nvSpPr>
             <p:spPr>
               <a:xfrm>
-                <a:off x="752450" y="5216687"/>
+                <a:off x="913726" y="4766437"/>
                 <a:ext cx="2023769" cy="415498"/>
               </a:xfrm>
               <a:prstGeom prst="rect">
                 <a:avLst/>
               </a:prstGeom>
               <a:blipFill>
-                <a:blip r:embed="rId13"/>
+                <a:blip r:embed="rId12"/>
                 <a:stretch>
                   <a:fillRect/>
                 </a:stretch>
@@ -6013,13 +6129,12 @@
           <p:cNvCxnSpPr>
             <a:cxnSpLocks/>
             <a:stCxn id="226" idx="3"/>
-            <a:endCxn id="234" idx="1"/>
           </p:cNvCxnSpPr>
           <p:nvPr/>
         </p:nvCxnSpPr>
         <p:spPr>
           <a:xfrm flipV="1">
-            <a:off x="2776219" y="5420412"/>
+            <a:off x="2937495" y="4970162"/>
             <a:ext cx="363893" cy="4024"/>
           </a:xfrm>
           <a:prstGeom prst="straightConnector1">
@@ -6058,14 +6173,13 @@
           </p:cNvPr>
           <p:cNvCxnSpPr>
             <a:cxnSpLocks/>
-            <a:stCxn id="234" idx="3"/>
             <a:endCxn id="238" idx="1"/>
           </p:cNvCxnSpPr>
           <p:nvPr/>
         </p:nvCxnSpPr>
         <p:spPr>
           <a:xfrm>
-            <a:off x="5471323" y="5420412"/>
+            <a:off x="5310817" y="4954139"/>
             <a:ext cx="315257" cy="0"/>
           </a:xfrm>
           <a:prstGeom prst="straightConnector1">
@@ -6109,7 +6223,7 @@
             </p:nvSpPr>
             <p:spPr>
               <a:xfrm>
-                <a:off x="5786580" y="5202788"/>
+                <a:off x="5626074" y="4736515"/>
                 <a:ext cx="2023769" cy="435247"/>
               </a:xfrm>
               <a:prstGeom prst="rect">
@@ -6219,14 +6333,14 @@
             </p:nvSpPr>
             <p:spPr>
               <a:xfrm>
-                <a:off x="5786580" y="5202788"/>
+                <a:off x="5626074" y="4736515"/>
                 <a:ext cx="2023769" cy="435247"/>
               </a:xfrm>
               <a:prstGeom prst="rect">
                 <a:avLst/>
               </a:prstGeom>
               <a:blipFill>
-                <a:blip r:embed="rId14"/>
+                <a:blip r:embed="rId13"/>
                 <a:stretch>
                   <a:fillRect/>
                 </a:stretch>
@@ -6250,6 +6364,110 @@
           </p:sp>
         </mc:Fallback>
       </mc:AlternateContent>
+      <p:pic>
+        <p:nvPicPr>
+          <p:cNvPr id="1026" name="Picture 2" descr="Logo for SimCenter's quoFEM Application.">
+            <a:extLst>
+              <a:ext uri="{FF2B5EF4-FFF2-40B4-BE49-F238E27FC236}">
+                <a16:creationId xmlns:a16="http://schemas.microsoft.com/office/drawing/2014/main" id="{F0346CDB-92F3-5D98-885E-9445A09BBACA}"/>
+              </a:ext>
+            </a:extLst>
+          </p:cNvPr>
+          <p:cNvPicPr>
+            <a:picLocks noChangeAspect="1" noChangeArrowheads="1"/>
+          </p:cNvPicPr>
+          <p:nvPr/>
+        </p:nvPicPr>
+        <p:blipFill>
+          <a:blip r:embed="rId14">
+            <a:extLst>
+              <a:ext uri="{28A0092B-C50C-407E-A947-70E740481C1C}">
+                <a14:useLocalDpi xmlns:a14="http://schemas.microsoft.com/office/drawing/2010/main" val="0"/>
+              </a:ext>
+            </a:extLst>
+          </a:blip>
+          <a:srcRect/>
+          <a:stretch>
+            <a:fillRect/>
+          </a:stretch>
+        </p:blipFill>
+        <p:spPr bwMode="auto">
+          <a:xfrm>
+            <a:off x="7175812" y="1165569"/>
+            <a:ext cx="521815" cy="521815"/>
+          </a:xfrm>
+          <a:prstGeom prst="rect">
+            <a:avLst/>
+          </a:prstGeom>
+          <a:noFill/>
+          <a:ln>
+            <a:solidFill>
+              <a:schemeClr val="tx1"/>
+            </a:solidFill>
+          </a:ln>
+          <a:extLst>
+            <a:ext uri="{909E8E84-426E-40DD-AFC4-6F175D3DCCD1}">
+              <a14:hiddenFill xmlns:a14="http://schemas.microsoft.com/office/drawing/2010/main">
+                <a:solidFill>
+                  <a:srgbClr val="FFFFFF"/>
+                </a:solidFill>
+              </a14:hiddenFill>
+            </a:ext>
+          </a:extLst>
+        </p:spPr>
+      </p:pic>
+      <p:pic>
+        <p:nvPicPr>
+          <p:cNvPr id="3" name="Picture 2" descr="Logo for SimCenter's quoFEM Application.">
+            <a:extLst>
+              <a:ext uri="{FF2B5EF4-FFF2-40B4-BE49-F238E27FC236}">
+                <a16:creationId xmlns:a16="http://schemas.microsoft.com/office/drawing/2014/main" id="{EFB03B26-6583-5311-73D3-FDAC7C3EAB78}"/>
+              </a:ext>
+            </a:extLst>
+          </p:cNvPr>
+          <p:cNvPicPr>
+            <a:picLocks noChangeAspect="1" noChangeArrowheads="1"/>
+          </p:cNvPicPr>
+          <p:nvPr/>
+        </p:nvPicPr>
+        <p:blipFill>
+          <a:blip r:embed="rId14">
+            <a:extLst>
+              <a:ext uri="{28A0092B-C50C-407E-A947-70E740481C1C}">
+                <a14:useLocalDpi xmlns:a14="http://schemas.microsoft.com/office/drawing/2010/main" val="0"/>
+              </a:ext>
+            </a:extLst>
+          </a:blip>
+          <a:srcRect/>
+          <a:stretch>
+            <a:fillRect/>
+          </a:stretch>
+        </p:blipFill>
+        <p:spPr bwMode="auto">
+          <a:xfrm>
+            <a:off x="4770714" y="4187268"/>
+            <a:ext cx="521815" cy="521815"/>
+          </a:xfrm>
+          <a:prstGeom prst="rect">
+            <a:avLst/>
+          </a:prstGeom>
+          <a:noFill/>
+          <a:ln>
+            <a:solidFill>
+              <a:schemeClr val="tx1"/>
+            </a:solidFill>
+          </a:ln>
+          <a:extLst>
+            <a:ext uri="{909E8E84-426E-40DD-AFC4-6F175D3DCCD1}">
+              <a14:hiddenFill xmlns:a14="http://schemas.microsoft.com/office/drawing/2010/main">
+                <a:solidFill>
+                  <a:srgbClr val="FFFFFF"/>
+                </a:solidFill>
+              </a14:hiddenFill>
+            </a:ext>
+          </a:extLst>
+        </p:spPr>
+      </p:pic>
     </p:spTree>
     <p:extLst>
       <p:ext uri="{BB962C8B-B14F-4D97-AF65-F5344CB8AC3E}">
@@ -6264,6 +6482,2053 @@
 </file>
 
 <file path=ppt/slides/slide2.xml><?xml version="1.0" encoding="utf-8"?>
+<p:sld xmlns:a="http://schemas.openxmlformats.org/drawingml/2006/main" xmlns:r="http://schemas.openxmlformats.org/officeDocument/2006/relationships" xmlns:p="http://schemas.openxmlformats.org/presentationml/2006/main">
+  <p:cSld>
+    <p:spTree>
+      <p:nvGrpSpPr>
+        <p:cNvPr id="1" name=""/>
+        <p:cNvGrpSpPr/>
+        <p:nvPr/>
+      </p:nvGrpSpPr>
+      <p:grpSpPr>
+        <a:xfrm>
+          <a:off x="0" y="0"/>
+          <a:ext cx="0" cy="0"/>
+          <a:chOff x="0" y="0"/>
+          <a:chExt cx="0" cy="0"/>
+        </a:xfrm>
+      </p:grpSpPr>
+      <p:sp>
+        <p:nvSpPr>
+          <p:cNvPr id="3" name="Rectangle 2">
+            <a:extLst>
+              <a:ext uri="{FF2B5EF4-FFF2-40B4-BE49-F238E27FC236}">
+                <a16:creationId xmlns:a16="http://schemas.microsoft.com/office/drawing/2014/main" id="{737E1CFF-6AC3-C08D-214B-E100F9951181}"/>
+              </a:ext>
+            </a:extLst>
+          </p:cNvPr>
+          <p:cNvSpPr/>
+          <p:nvPr/>
+        </p:nvSpPr>
+        <p:spPr>
+          <a:xfrm>
+            <a:off x="3762257" y="4360721"/>
+            <a:ext cx="796841" cy="294252"/>
+          </a:xfrm>
+          <a:prstGeom prst="rect">
+            <a:avLst/>
+          </a:prstGeom>
+          <a:solidFill>
+            <a:schemeClr val="bg2">
+              <a:lumMod val="90000"/>
+            </a:schemeClr>
+          </a:solidFill>
+          <a:ln>
+            <a:noFill/>
+          </a:ln>
+        </p:spPr>
+        <p:style>
+          <a:lnRef idx="2">
+            <a:schemeClr val="accent1">
+              <a:shade val="15000"/>
+            </a:schemeClr>
+          </a:lnRef>
+          <a:fillRef idx="1">
+            <a:schemeClr val="accent1"/>
+          </a:fillRef>
+          <a:effectRef idx="0">
+            <a:schemeClr val="accent1"/>
+          </a:effectRef>
+          <a:fontRef idx="minor">
+            <a:schemeClr val="lt1"/>
+          </a:fontRef>
+        </p:style>
+        <p:txBody>
+          <a:bodyPr rtlCol="0" anchor="ctr"/>
+          <a:lstStyle/>
+          <a:p>
+            <a:pPr algn="ctr"/>
+            <a:endParaRPr lang="en-US" sz="1350"/>
+          </a:p>
+        </p:txBody>
+      </p:sp>
+      <p:cxnSp>
+        <p:nvCxnSpPr>
+          <p:cNvPr id="4" name="Straight Connector 3">
+            <a:extLst>
+              <a:ext uri="{FF2B5EF4-FFF2-40B4-BE49-F238E27FC236}">
+                <a16:creationId xmlns:a16="http://schemas.microsoft.com/office/drawing/2014/main" id="{9E213604-308C-5153-7956-5448E3E88021}"/>
+              </a:ext>
+            </a:extLst>
+          </p:cNvPr>
+          <p:cNvCxnSpPr>
+            <a:cxnSpLocks/>
+          </p:cNvCxnSpPr>
+          <p:nvPr/>
+        </p:nvCxnSpPr>
+        <p:spPr>
+          <a:xfrm flipV="1">
+            <a:off x="4178161" y="2054458"/>
+            <a:ext cx="623088" cy="2180759"/>
+          </a:xfrm>
+          <a:prstGeom prst="line">
+            <a:avLst/>
+          </a:prstGeom>
+          <a:ln w="6350"/>
+        </p:spPr>
+        <p:style>
+          <a:lnRef idx="2">
+            <a:schemeClr val="dk1"/>
+          </a:lnRef>
+          <a:fillRef idx="0">
+            <a:schemeClr val="dk1"/>
+          </a:fillRef>
+          <a:effectRef idx="1">
+            <a:schemeClr val="dk1"/>
+          </a:effectRef>
+          <a:fontRef idx="minor">
+            <a:schemeClr val="tx1"/>
+          </a:fontRef>
+        </p:style>
+      </p:cxnSp>
+      <p:cxnSp>
+        <p:nvCxnSpPr>
+          <p:cNvPr id="5" name="Straight Connector 4">
+            <a:extLst>
+              <a:ext uri="{FF2B5EF4-FFF2-40B4-BE49-F238E27FC236}">
+                <a16:creationId xmlns:a16="http://schemas.microsoft.com/office/drawing/2014/main" id="{B1E3B431-1452-80DE-3BBB-20655BFC6ED6}"/>
+              </a:ext>
+            </a:extLst>
+          </p:cNvPr>
+          <p:cNvCxnSpPr>
+            <a:cxnSpLocks/>
+          </p:cNvCxnSpPr>
+          <p:nvPr/>
+        </p:nvCxnSpPr>
+        <p:spPr>
+          <a:xfrm>
+            <a:off x="4160677" y="2057772"/>
+            <a:ext cx="17484" cy="2302949"/>
+          </a:xfrm>
+          <a:prstGeom prst="line">
+            <a:avLst/>
+          </a:prstGeom>
+          <a:ln w="38100"/>
+        </p:spPr>
+        <p:style>
+          <a:lnRef idx="2">
+            <a:schemeClr val="dk1"/>
+          </a:lnRef>
+          <a:fillRef idx="0">
+            <a:schemeClr val="dk1"/>
+          </a:fillRef>
+          <a:effectRef idx="1">
+            <a:schemeClr val="dk1"/>
+          </a:effectRef>
+          <a:fontRef idx="minor">
+            <a:schemeClr val="tx1"/>
+          </a:fontRef>
+        </p:style>
+      </p:cxnSp>
+      <p:cxnSp>
+        <p:nvCxnSpPr>
+          <p:cNvPr id="6" name="Straight Connector 5">
+            <a:extLst>
+              <a:ext uri="{FF2B5EF4-FFF2-40B4-BE49-F238E27FC236}">
+                <a16:creationId xmlns:a16="http://schemas.microsoft.com/office/drawing/2014/main" id="{E017A69B-BBC6-33DF-4C85-F40315AC2697}"/>
+              </a:ext>
+            </a:extLst>
+          </p:cNvPr>
+          <p:cNvCxnSpPr/>
+          <p:nvPr/>
+        </p:nvCxnSpPr>
+        <p:spPr>
+          <a:xfrm>
+            <a:off x="3762257" y="4360721"/>
+            <a:ext cx="796841" cy="0"/>
+          </a:xfrm>
+          <a:prstGeom prst="line">
+            <a:avLst/>
+          </a:prstGeom>
+        </p:spPr>
+        <p:style>
+          <a:lnRef idx="2">
+            <a:schemeClr val="dk1"/>
+          </a:lnRef>
+          <a:fillRef idx="0">
+            <a:schemeClr val="dk1"/>
+          </a:fillRef>
+          <a:effectRef idx="1">
+            <a:schemeClr val="dk1"/>
+          </a:effectRef>
+          <a:fontRef idx="minor">
+            <a:schemeClr val="tx1"/>
+          </a:fontRef>
+        </p:style>
+      </p:cxnSp>
+      <mc:AlternateContent xmlns:mc="http://schemas.openxmlformats.org/markup-compatibility/2006" xmlns:a14="http://schemas.microsoft.com/office/drawing/2010/main">
+        <mc:Choice Requires="a14">
+          <p:sp>
+            <p:nvSpPr>
+              <p:cNvPr id="7" name="TextBox 6">
+                <a:extLst>
+                  <a:ext uri="{FF2B5EF4-FFF2-40B4-BE49-F238E27FC236}">
+                    <a16:creationId xmlns:a16="http://schemas.microsoft.com/office/drawing/2014/main" id="{4A30E107-0BB1-FD85-495C-D6DA79B403C1}"/>
+                  </a:ext>
+                </a:extLst>
+              </p:cNvPr>
+              <p:cNvSpPr txBox="1"/>
+              <p:nvPr/>
+            </p:nvSpPr>
+            <p:spPr>
+              <a:xfrm rot="16200000">
+                <a:off x="3652199" y="2614900"/>
+                <a:ext cx="678403" cy="338554"/>
+              </a:xfrm>
+              <a:prstGeom prst="rect">
+                <a:avLst/>
+              </a:prstGeom>
+              <a:noFill/>
+            </p:spPr>
+            <p:txBody>
+              <a:bodyPr wrap="square" rtlCol="0">
+                <a:spAutoFit/>
+              </a:bodyPr>
+              <a:lstStyle/>
+              <a:p>
+                <a:pPr/>
+                <a14:m>
+                  <m:oMathPara xmlns:m="http://schemas.openxmlformats.org/officeDocument/2006/math">
+                    <m:oMathParaPr>
+                      <m:jc m:val="centerGroup"/>
+                    </m:oMathParaPr>
+                    <m:oMath xmlns:m="http://schemas.openxmlformats.org/officeDocument/2006/math">
+                      <m:r>
+                        <a:rPr lang="en-US" sz="1600" i="1">
+                          <a:latin typeface="Cambria Math" panose="02040503050406030204" pitchFamily="18" charset="0"/>
+                        </a:rPr>
+                        <m:t>𝐸𝐼</m:t>
+                      </m:r>
+                      <m:r>
+                        <a:rPr lang="en-US" sz="1600" i="1">
+                          <a:latin typeface="Cambria Math" panose="02040503050406030204" pitchFamily="18" charset="0"/>
+                        </a:rPr>
+                        <m:t>, </m:t>
+                      </m:r>
+                      <m:r>
+                        <a:rPr lang="en-US" sz="1600" i="1">
+                          <a:latin typeface="Cambria Math" panose="02040503050406030204" pitchFamily="18" charset="0"/>
+                        </a:rPr>
+                        <m:t>𝐿</m:t>
+                      </m:r>
+                    </m:oMath>
+                  </m:oMathPara>
+                </a14:m>
+                <a:endParaRPr lang="en-US" sz="1600" dirty="0"/>
+              </a:p>
+            </p:txBody>
+          </p:sp>
+        </mc:Choice>
+        <mc:Fallback xmlns="">
+          <p:sp>
+            <p:nvSpPr>
+              <p:cNvPr id="7" name="TextBox 6">
+                <a:extLst>
+                  <a:ext uri="{FF2B5EF4-FFF2-40B4-BE49-F238E27FC236}">
+                    <a16:creationId xmlns:a16="http://schemas.microsoft.com/office/drawing/2014/main" id="{4A30E107-0BB1-FD85-495C-D6DA79B403C1}"/>
+                  </a:ext>
+                </a:extLst>
+              </p:cNvPr>
+              <p:cNvSpPr txBox="1">
+                <a:spLocks noRot="1" noChangeAspect="1" noMove="1" noResize="1" noEditPoints="1" noAdjustHandles="1" noChangeArrowheads="1" noChangeShapeType="1" noTextEdit="1"/>
+              </p:cNvSpPr>
+              <p:nvPr/>
+            </p:nvSpPr>
+            <p:spPr>
+              <a:xfrm rot="16200000">
+                <a:off x="3652199" y="2614900"/>
+                <a:ext cx="678403" cy="338554"/>
+              </a:xfrm>
+              <a:prstGeom prst="rect">
+                <a:avLst/>
+              </a:prstGeom>
+              <a:blipFill>
+                <a:blip r:embed="rId2"/>
+                <a:stretch>
+                  <a:fillRect/>
+                </a:stretch>
+              </a:blipFill>
+            </p:spPr>
+            <p:txBody>
+              <a:bodyPr/>
+              <a:lstStyle/>
+              <a:p>
+                <a:r>
+                  <a:rPr lang="en-US">
+                    <a:noFill/>
+                  </a:rPr>
+                  <a:t> </a:t>
+                </a:r>
+              </a:p>
+            </p:txBody>
+          </p:sp>
+        </mc:Fallback>
+      </mc:AlternateContent>
+      <p:sp>
+        <p:nvSpPr>
+          <p:cNvPr id="8" name="Freeform 7">
+            <a:extLst>
+              <a:ext uri="{FF2B5EF4-FFF2-40B4-BE49-F238E27FC236}">
+                <a16:creationId xmlns:a16="http://schemas.microsoft.com/office/drawing/2014/main" id="{E351133B-86F5-6A57-A71B-306EFD293900}"/>
+              </a:ext>
+            </a:extLst>
+          </p:cNvPr>
+          <p:cNvSpPr/>
+          <p:nvPr/>
+        </p:nvSpPr>
+        <p:spPr>
+          <a:xfrm>
+            <a:off x="4188949" y="2054457"/>
+            <a:ext cx="926258" cy="2137238"/>
+          </a:xfrm>
+          <a:custGeom>
+            <a:avLst/>
+            <a:gdLst>
+              <a:gd name="connsiteX0" fmla="*/ 0 w 632059"/>
+              <a:gd name="connsiteY0" fmla="*/ 1411705 h 1411705"/>
+              <a:gd name="connsiteX1" fmla="*/ 269507 w 632059"/>
+              <a:gd name="connsiteY1" fmla="*/ 676977 h 1411705"/>
+              <a:gd name="connsiteX2" fmla="*/ 632059 w 632059"/>
+              <a:gd name="connsiteY2" fmla="*/ 0 h 1411705"/>
+            </a:gdLst>
+            <a:ahLst/>
+            <a:cxnLst>
+              <a:cxn ang="0">
+                <a:pos x="connsiteX0" y="connsiteY0"/>
+              </a:cxn>
+              <a:cxn ang="0">
+                <a:pos x="connsiteX1" y="connsiteY1"/>
+              </a:cxn>
+              <a:cxn ang="0">
+                <a:pos x="connsiteX2" y="connsiteY2"/>
+              </a:cxn>
+            </a:cxnLst>
+            <a:rect l="l" t="t" r="r" b="b"/>
+            <a:pathLst>
+              <a:path w="632059" h="1411705">
+                <a:moveTo>
+                  <a:pt x="0" y="1411705"/>
+                </a:moveTo>
+                <a:cubicBezTo>
+                  <a:pt x="82082" y="1161983"/>
+                  <a:pt x="164164" y="912261"/>
+                  <a:pt x="269507" y="676977"/>
+                </a:cubicBezTo>
+                <a:cubicBezTo>
+                  <a:pt x="374850" y="441693"/>
+                  <a:pt x="503454" y="220846"/>
+                  <a:pt x="632059" y="0"/>
+                </a:cubicBezTo>
+              </a:path>
+            </a:pathLst>
+          </a:custGeom>
+          <a:noFill/>
+        </p:spPr>
+        <p:style>
+          <a:lnRef idx="2">
+            <a:schemeClr val="accent1">
+              <a:shade val="15000"/>
+            </a:schemeClr>
+          </a:lnRef>
+          <a:fillRef idx="1">
+            <a:schemeClr val="accent1"/>
+          </a:fillRef>
+          <a:effectRef idx="0">
+            <a:schemeClr val="accent1"/>
+          </a:effectRef>
+          <a:fontRef idx="minor">
+            <a:schemeClr val="lt1"/>
+          </a:fontRef>
+        </p:style>
+        <p:txBody>
+          <a:bodyPr rtlCol="0" anchor="ctr"/>
+          <a:lstStyle/>
+          <a:p>
+            <a:pPr algn="ctr"/>
+            <a:endParaRPr lang="en-US" sz="1350"/>
+          </a:p>
+        </p:txBody>
+      </p:sp>
+      <p:sp>
+        <p:nvSpPr>
+          <p:cNvPr id="9" name="Oval 8">
+            <a:extLst>
+              <a:ext uri="{FF2B5EF4-FFF2-40B4-BE49-F238E27FC236}">
+                <a16:creationId xmlns:a16="http://schemas.microsoft.com/office/drawing/2014/main" id="{230823F1-6BDB-95A0-502B-AF887003AD13}"/>
+              </a:ext>
+            </a:extLst>
+          </p:cNvPr>
+          <p:cNvSpPr>
+            <a:spLocks noChangeAspect="1"/>
+          </p:cNvSpPr>
+          <p:nvPr/>
+        </p:nvSpPr>
+        <p:spPr>
+          <a:xfrm>
+            <a:off x="4102004" y="4108011"/>
+            <a:ext cx="143258" cy="143818"/>
+          </a:xfrm>
+          <a:prstGeom prst="ellipse">
+            <a:avLst/>
+          </a:prstGeom>
+          <a:solidFill>
+            <a:srgbClr val="FF0000"/>
+          </a:solidFill>
+        </p:spPr>
+        <p:style>
+          <a:lnRef idx="2">
+            <a:schemeClr val="accent1">
+              <a:shade val="15000"/>
+            </a:schemeClr>
+          </a:lnRef>
+          <a:fillRef idx="1">
+            <a:schemeClr val="accent1"/>
+          </a:fillRef>
+          <a:effectRef idx="0">
+            <a:schemeClr val="accent1"/>
+          </a:effectRef>
+          <a:fontRef idx="minor">
+            <a:schemeClr val="lt1"/>
+          </a:fontRef>
+        </p:style>
+        <p:txBody>
+          <a:bodyPr rtlCol="0" anchor="ctr"/>
+          <a:lstStyle/>
+          <a:p>
+            <a:pPr algn="ctr"/>
+            <a:endParaRPr lang="en-US" sz="1350"/>
+          </a:p>
+        </p:txBody>
+      </p:sp>
+      <p:sp>
+        <p:nvSpPr>
+          <p:cNvPr id="11" name="Rectangle 10">
+            <a:extLst>
+              <a:ext uri="{FF2B5EF4-FFF2-40B4-BE49-F238E27FC236}">
+                <a16:creationId xmlns:a16="http://schemas.microsoft.com/office/drawing/2014/main" id="{ED65E3C5-98BC-F150-DE6D-2C0E4495CFCD}"/>
+              </a:ext>
+            </a:extLst>
+          </p:cNvPr>
+          <p:cNvSpPr/>
+          <p:nvPr/>
+        </p:nvSpPr>
+        <p:spPr>
+          <a:xfrm>
+            <a:off x="2222002" y="4360721"/>
+            <a:ext cx="796841" cy="294252"/>
+          </a:xfrm>
+          <a:prstGeom prst="rect">
+            <a:avLst/>
+          </a:prstGeom>
+          <a:solidFill>
+            <a:schemeClr val="bg2">
+              <a:lumMod val="90000"/>
+            </a:schemeClr>
+          </a:solidFill>
+          <a:ln>
+            <a:noFill/>
+          </a:ln>
+        </p:spPr>
+        <p:style>
+          <a:lnRef idx="2">
+            <a:schemeClr val="accent1">
+              <a:shade val="15000"/>
+            </a:schemeClr>
+          </a:lnRef>
+          <a:fillRef idx="1">
+            <a:schemeClr val="accent1"/>
+          </a:fillRef>
+          <a:effectRef idx="0">
+            <a:schemeClr val="accent1"/>
+          </a:effectRef>
+          <a:fontRef idx="minor">
+            <a:schemeClr val="lt1"/>
+          </a:fontRef>
+        </p:style>
+        <p:txBody>
+          <a:bodyPr rtlCol="0" anchor="ctr"/>
+          <a:lstStyle/>
+          <a:p>
+            <a:pPr algn="ctr"/>
+            <a:endParaRPr lang="en-US" sz="1350"/>
+          </a:p>
+        </p:txBody>
+      </p:sp>
+      <p:sp>
+        <p:nvSpPr>
+          <p:cNvPr id="18" name="Rectangle 17">
+            <a:extLst>
+              <a:ext uri="{FF2B5EF4-FFF2-40B4-BE49-F238E27FC236}">
+                <a16:creationId xmlns:a16="http://schemas.microsoft.com/office/drawing/2014/main" id="{BA6B012C-65FB-3B2B-AA6F-9D915D4F943B}"/>
+              </a:ext>
+            </a:extLst>
+          </p:cNvPr>
+          <p:cNvSpPr/>
+          <p:nvPr/>
+        </p:nvSpPr>
+        <p:spPr>
+          <a:xfrm>
+            <a:off x="2406862" y="2057772"/>
+            <a:ext cx="427120" cy="2302244"/>
+          </a:xfrm>
+          <a:prstGeom prst="rect">
+            <a:avLst/>
+          </a:prstGeom>
+          <a:solidFill>
+            <a:schemeClr val="bg2">
+              <a:lumMod val="90000"/>
+            </a:schemeClr>
+          </a:solidFill>
+          <a:ln>
+            <a:noFill/>
+          </a:ln>
+        </p:spPr>
+        <p:style>
+          <a:lnRef idx="2">
+            <a:schemeClr val="accent1">
+              <a:shade val="15000"/>
+            </a:schemeClr>
+          </a:lnRef>
+          <a:fillRef idx="1">
+            <a:schemeClr val="accent1"/>
+          </a:fillRef>
+          <a:effectRef idx="0">
+            <a:schemeClr val="accent1"/>
+          </a:effectRef>
+          <a:fontRef idx="minor">
+            <a:schemeClr val="lt1"/>
+          </a:fontRef>
+        </p:style>
+        <p:txBody>
+          <a:bodyPr rtlCol="0" anchor="ctr"/>
+          <a:lstStyle/>
+          <a:p>
+            <a:pPr algn="ctr"/>
+            <a:endParaRPr lang="en-US" sz="1350"/>
+          </a:p>
+        </p:txBody>
+      </p:sp>
+      <p:cxnSp>
+        <p:nvCxnSpPr>
+          <p:cNvPr id="19" name="Straight Connector 18">
+            <a:extLst>
+              <a:ext uri="{FF2B5EF4-FFF2-40B4-BE49-F238E27FC236}">
+                <a16:creationId xmlns:a16="http://schemas.microsoft.com/office/drawing/2014/main" id="{46161098-530B-AAE8-4E7F-6099F29B597C}"/>
+              </a:ext>
+            </a:extLst>
+          </p:cNvPr>
+          <p:cNvCxnSpPr/>
+          <p:nvPr/>
+        </p:nvCxnSpPr>
+        <p:spPr>
+          <a:xfrm>
+            <a:off x="2222002" y="4360016"/>
+            <a:ext cx="796841" cy="0"/>
+          </a:xfrm>
+          <a:prstGeom prst="line">
+            <a:avLst/>
+          </a:prstGeom>
+        </p:spPr>
+        <p:style>
+          <a:lnRef idx="2">
+            <a:schemeClr val="dk1"/>
+          </a:lnRef>
+          <a:fillRef idx="0">
+            <a:schemeClr val="dk1"/>
+          </a:fillRef>
+          <a:effectRef idx="1">
+            <a:schemeClr val="dk1"/>
+          </a:effectRef>
+          <a:fontRef idx="minor">
+            <a:schemeClr val="tx1"/>
+          </a:fontRef>
+        </p:style>
+      </p:cxnSp>
+      <p:sp>
+        <p:nvSpPr>
+          <p:cNvPr id="20" name="Rectangle 19">
+            <a:extLst>
+              <a:ext uri="{FF2B5EF4-FFF2-40B4-BE49-F238E27FC236}">
+                <a16:creationId xmlns:a16="http://schemas.microsoft.com/office/drawing/2014/main" id="{20389835-1A54-5553-A073-F8B36C4B21DA}"/>
+              </a:ext>
+            </a:extLst>
+          </p:cNvPr>
+          <p:cNvSpPr/>
+          <p:nvPr/>
+        </p:nvSpPr>
+        <p:spPr>
+          <a:xfrm>
+            <a:off x="2403949" y="2039815"/>
+            <a:ext cx="720419" cy="2319497"/>
+          </a:xfrm>
+          <a:custGeom>
+            <a:avLst/>
+            <a:gdLst>
+              <a:gd name="connsiteX0" fmla="*/ 0 w 427120"/>
+              <a:gd name="connsiteY0" fmla="*/ 0 h 2302244"/>
+              <a:gd name="connsiteX1" fmla="*/ 427120 w 427120"/>
+              <a:gd name="connsiteY1" fmla="*/ 0 h 2302244"/>
+              <a:gd name="connsiteX2" fmla="*/ 427120 w 427120"/>
+              <a:gd name="connsiteY2" fmla="*/ 2302244 h 2302244"/>
+              <a:gd name="connsiteX3" fmla="*/ 0 w 427120"/>
+              <a:gd name="connsiteY3" fmla="*/ 2302244 h 2302244"/>
+              <a:gd name="connsiteX4" fmla="*/ 0 w 427120"/>
+              <a:gd name="connsiteY4" fmla="*/ 0 h 2302244"/>
+              <a:gd name="connsiteX0" fmla="*/ 0 w 685913"/>
+              <a:gd name="connsiteY0" fmla="*/ 0 h 2302244"/>
+              <a:gd name="connsiteX1" fmla="*/ 685913 w 685913"/>
+              <a:gd name="connsiteY1" fmla="*/ 28755 h 2302244"/>
+              <a:gd name="connsiteX2" fmla="*/ 427120 w 685913"/>
+              <a:gd name="connsiteY2" fmla="*/ 2302244 h 2302244"/>
+              <a:gd name="connsiteX3" fmla="*/ 0 w 685913"/>
+              <a:gd name="connsiteY3" fmla="*/ 2302244 h 2302244"/>
+              <a:gd name="connsiteX4" fmla="*/ 0 w 685913"/>
+              <a:gd name="connsiteY4" fmla="*/ 0 h 2302244"/>
+              <a:gd name="connsiteX0" fmla="*/ 281797 w 685913"/>
+              <a:gd name="connsiteY0" fmla="*/ 0 h 2302244"/>
+              <a:gd name="connsiteX1" fmla="*/ 685913 w 685913"/>
+              <a:gd name="connsiteY1" fmla="*/ 28755 h 2302244"/>
+              <a:gd name="connsiteX2" fmla="*/ 427120 w 685913"/>
+              <a:gd name="connsiteY2" fmla="*/ 2302244 h 2302244"/>
+              <a:gd name="connsiteX3" fmla="*/ 0 w 685913"/>
+              <a:gd name="connsiteY3" fmla="*/ 2302244 h 2302244"/>
+              <a:gd name="connsiteX4" fmla="*/ 281797 w 685913"/>
+              <a:gd name="connsiteY4" fmla="*/ 0 h 2302244"/>
+              <a:gd name="connsiteX0" fmla="*/ 281797 w 685913"/>
+              <a:gd name="connsiteY0" fmla="*/ 0 h 2302244"/>
+              <a:gd name="connsiteX1" fmla="*/ 685913 w 685913"/>
+              <a:gd name="connsiteY1" fmla="*/ 28755 h 2302244"/>
+              <a:gd name="connsiteX2" fmla="*/ 427120 w 685913"/>
+              <a:gd name="connsiteY2" fmla="*/ 2302244 h 2302244"/>
+              <a:gd name="connsiteX3" fmla="*/ 0 w 685913"/>
+              <a:gd name="connsiteY3" fmla="*/ 2302244 h 2302244"/>
+              <a:gd name="connsiteX4" fmla="*/ 281797 w 685913"/>
+              <a:gd name="connsiteY4" fmla="*/ 0 h 2302244"/>
+              <a:gd name="connsiteX0" fmla="*/ 281797 w 685913"/>
+              <a:gd name="connsiteY0" fmla="*/ 0 h 2302244"/>
+              <a:gd name="connsiteX1" fmla="*/ 685913 w 685913"/>
+              <a:gd name="connsiteY1" fmla="*/ 28755 h 2302244"/>
+              <a:gd name="connsiteX2" fmla="*/ 427120 w 685913"/>
+              <a:gd name="connsiteY2" fmla="*/ 2302244 h 2302244"/>
+              <a:gd name="connsiteX3" fmla="*/ 0 w 685913"/>
+              <a:gd name="connsiteY3" fmla="*/ 2302244 h 2302244"/>
+              <a:gd name="connsiteX4" fmla="*/ 281797 w 685913"/>
+              <a:gd name="connsiteY4" fmla="*/ 0 h 2302244"/>
+              <a:gd name="connsiteX0" fmla="*/ 281797 w 685913"/>
+              <a:gd name="connsiteY0" fmla="*/ 0 h 2302244"/>
+              <a:gd name="connsiteX1" fmla="*/ 685913 w 685913"/>
+              <a:gd name="connsiteY1" fmla="*/ 28755 h 2302244"/>
+              <a:gd name="connsiteX2" fmla="*/ 427120 w 685913"/>
+              <a:gd name="connsiteY2" fmla="*/ 2302244 h 2302244"/>
+              <a:gd name="connsiteX3" fmla="*/ 0 w 685913"/>
+              <a:gd name="connsiteY3" fmla="*/ 2302244 h 2302244"/>
+              <a:gd name="connsiteX4" fmla="*/ 281797 w 685913"/>
+              <a:gd name="connsiteY4" fmla="*/ 0 h 2302244"/>
+              <a:gd name="connsiteX0" fmla="*/ 281797 w 685913"/>
+              <a:gd name="connsiteY0" fmla="*/ 0 h 2302244"/>
+              <a:gd name="connsiteX1" fmla="*/ 685913 w 685913"/>
+              <a:gd name="connsiteY1" fmla="*/ 28755 h 2302244"/>
+              <a:gd name="connsiteX2" fmla="*/ 427120 w 685913"/>
+              <a:gd name="connsiteY2" fmla="*/ 2302244 h 2302244"/>
+              <a:gd name="connsiteX3" fmla="*/ 0 w 685913"/>
+              <a:gd name="connsiteY3" fmla="*/ 2302244 h 2302244"/>
+              <a:gd name="connsiteX4" fmla="*/ 281797 w 685913"/>
+              <a:gd name="connsiteY4" fmla="*/ 0 h 2302244"/>
+              <a:gd name="connsiteX0" fmla="*/ 281797 w 720419"/>
+              <a:gd name="connsiteY0" fmla="*/ 0 h 2302244"/>
+              <a:gd name="connsiteX1" fmla="*/ 720419 w 720419"/>
+              <a:gd name="connsiteY1" fmla="*/ 40257 h 2302244"/>
+              <a:gd name="connsiteX2" fmla="*/ 427120 w 720419"/>
+              <a:gd name="connsiteY2" fmla="*/ 2302244 h 2302244"/>
+              <a:gd name="connsiteX3" fmla="*/ 0 w 720419"/>
+              <a:gd name="connsiteY3" fmla="*/ 2302244 h 2302244"/>
+              <a:gd name="connsiteX4" fmla="*/ 281797 w 720419"/>
+              <a:gd name="connsiteY4" fmla="*/ 0 h 2302244"/>
+              <a:gd name="connsiteX0" fmla="*/ 281797 w 720419"/>
+              <a:gd name="connsiteY0" fmla="*/ 0 h 2319497"/>
+              <a:gd name="connsiteX1" fmla="*/ 720419 w 720419"/>
+              <a:gd name="connsiteY1" fmla="*/ 57510 h 2319497"/>
+              <a:gd name="connsiteX2" fmla="*/ 427120 w 720419"/>
+              <a:gd name="connsiteY2" fmla="*/ 2319497 h 2319497"/>
+              <a:gd name="connsiteX3" fmla="*/ 0 w 720419"/>
+              <a:gd name="connsiteY3" fmla="*/ 2319497 h 2319497"/>
+              <a:gd name="connsiteX4" fmla="*/ 281797 w 720419"/>
+              <a:gd name="connsiteY4" fmla="*/ 0 h 2319497"/>
+            </a:gdLst>
+            <a:ahLst/>
+            <a:cxnLst>
+              <a:cxn ang="0">
+                <a:pos x="connsiteX0" y="connsiteY0"/>
+              </a:cxn>
+              <a:cxn ang="0">
+                <a:pos x="connsiteX1" y="connsiteY1"/>
+              </a:cxn>
+              <a:cxn ang="0">
+                <a:pos x="connsiteX2" y="connsiteY2"/>
+              </a:cxn>
+              <a:cxn ang="0">
+                <a:pos x="connsiteX3" y="connsiteY3"/>
+              </a:cxn>
+              <a:cxn ang="0">
+                <a:pos x="connsiteX4" y="connsiteY4"/>
+              </a:cxn>
+            </a:cxnLst>
+            <a:rect l="l" t="t" r="r" b="b"/>
+            <a:pathLst>
+              <a:path w="720419" h="2319497">
+                <a:moveTo>
+                  <a:pt x="281797" y="0"/>
+                </a:moveTo>
+                <a:lnTo>
+                  <a:pt x="720419" y="57510"/>
+                </a:lnTo>
+                <a:cubicBezTo>
+                  <a:pt x="576646" y="821091"/>
+                  <a:pt x="427120" y="1567418"/>
+                  <a:pt x="427120" y="2319497"/>
+                </a:cubicBezTo>
+                <a:lnTo>
+                  <a:pt x="0" y="2319497"/>
+                </a:lnTo>
+                <a:cubicBezTo>
+                  <a:pt x="1917" y="1557833"/>
+                  <a:pt x="136107" y="761664"/>
+                  <a:pt x="281797" y="0"/>
+                </a:cubicBezTo>
+                <a:close/>
+              </a:path>
+            </a:pathLst>
+          </a:custGeom>
+          <a:solidFill>
+            <a:schemeClr val="bg2">
+              <a:lumMod val="90000"/>
+            </a:schemeClr>
+          </a:solidFill>
+          <a:ln>
+            <a:solidFill>
+              <a:schemeClr val="tx1"/>
+            </a:solidFill>
+          </a:ln>
+        </p:spPr>
+        <p:style>
+          <a:lnRef idx="2">
+            <a:schemeClr val="accent1">
+              <a:shade val="15000"/>
+            </a:schemeClr>
+          </a:lnRef>
+          <a:fillRef idx="1">
+            <a:schemeClr val="accent1"/>
+          </a:fillRef>
+          <a:effectRef idx="0">
+            <a:schemeClr val="accent1"/>
+          </a:effectRef>
+          <a:fontRef idx="minor">
+            <a:schemeClr val="lt1"/>
+          </a:fontRef>
+        </p:style>
+        <p:txBody>
+          <a:bodyPr rtlCol="0" anchor="ctr"/>
+          <a:lstStyle/>
+          <a:p>
+            <a:pPr algn="ctr"/>
+            <a:endParaRPr lang="en-US" sz="1350"/>
+          </a:p>
+        </p:txBody>
+      </p:sp>
+      <mc:AlternateContent xmlns:mc="http://schemas.openxmlformats.org/markup-compatibility/2006" xmlns:p14="http://schemas.microsoft.com/office/powerpoint/2010/main">
+        <mc:Choice Requires="p14">
+          <p:contentPart p14:bwMode="auto" r:id="rId3">
+            <p14:nvContentPartPr>
+              <p14:cNvPr id="30" name="Ink 29">
+                <a:extLst>
+                  <a:ext uri="{FF2B5EF4-FFF2-40B4-BE49-F238E27FC236}">
+                    <a16:creationId xmlns:a16="http://schemas.microsoft.com/office/drawing/2014/main" id="{3CBE5E1F-6A45-2E5A-7BA6-08C0506752A2}"/>
+                  </a:ext>
+                </a:extLst>
+              </p14:cNvPr>
+              <p14:cNvContentPartPr/>
+              <p14:nvPr/>
+            </p14:nvContentPartPr>
+            <p14:xfrm>
+              <a:off x="2408059" y="4291600"/>
+              <a:ext cx="203760" cy="32040"/>
+            </p14:xfrm>
+          </p:contentPart>
+        </mc:Choice>
+        <mc:Fallback xmlns="">
+          <p:pic>
+            <p:nvPicPr>
+              <p:cNvPr id="30" name="Ink 29">
+                <a:extLst>
+                  <a:ext uri="{FF2B5EF4-FFF2-40B4-BE49-F238E27FC236}">
+                    <a16:creationId xmlns:a16="http://schemas.microsoft.com/office/drawing/2014/main" id="{3CBE5E1F-6A45-2E5A-7BA6-08C0506752A2}"/>
+                  </a:ext>
+                </a:extLst>
+              </p:cNvPr>
+              <p:cNvPicPr/>
+              <p:nvPr/>
+            </p:nvPicPr>
+            <p:blipFill>
+              <a:blip r:embed="rId4"/>
+              <a:stretch>
+                <a:fillRect/>
+              </a:stretch>
+            </p:blipFill>
+            <p:spPr>
+              <a:xfrm>
+                <a:off x="2401939" y="4285480"/>
+                <a:ext cx="216000" cy="44280"/>
+              </a:xfrm>
+              <a:prstGeom prst="rect">
+                <a:avLst/>
+              </a:prstGeom>
+            </p:spPr>
+          </p:pic>
+        </mc:Fallback>
+      </mc:AlternateContent>
+      <p:grpSp>
+        <p:nvGrpSpPr>
+          <p:cNvPr id="37" name="Group 36">
+            <a:extLst>
+              <a:ext uri="{FF2B5EF4-FFF2-40B4-BE49-F238E27FC236}">
+                <a16:creationId xmlns:a16="http://schemas.microsoft.com/office/drawing/2014/main" id="{32D29FFA-3151-49A9-07B8-9F61B03C10F8}"/>
+              </a:ext>
+            </a:extLst>
+          </p:cNvPr>
+          <p:cNvGrpSpPr/>
+          <p:nvPr/>
+        </p:nvGrpSpPr>
+        <p:grpSpPr>
+          <a:xfrm>
+            <a:off x="2418139" y="3885160"/>
+            <a:ext cx="183960" cy="357120"/>
+            <a:chOff x="2500435" y="3336520"/>
+            <a:chExt cx="183960" cy="357120"/>
+          </a:xfrm>
+        </p:grpSpPr>
+        <mc:AlternateContent xmlns:mc="http://schemas.openxmlformats.org/markup-compatibility/2006" xmlns:p14="http://schemas.microsoft.com/office/powerpoint/2010/main">
+          <mc:Choice Requires="p14">
+            <p:contentPart p14:bwMode="auto" r:id="rId5">
+              <p14:nvContentPartPr>
+                <p14:cNvPr id="31" name="Ink 30">
+                  <a:extLst>
+                    <a:ext uri="{FF2B5EF4-FFF2-40B4-BE49-F238E27FC236}">
+                      <a16:creationId xmlns:a16="http://schemas.microsoft.com/office/drawing/2014/main" id="{AC59A9D6-A02C-BA25-0F2A-C6289C1C42CD}"/>
+                    </a:ext>
+                  </a:extLst>
+                </p14:cNvPr>
+                <p14:cNvContentPartPr/>
+                <p14:nvPr/>
+              </p14:nvContentPartPr>
+              <p14:xfrm>
+                <a:off x="2500435" y="3636760"/>
+                <a:ext cx="183960" cy="56880"/>
+              </p14:xfrm>
+            </p:contentPart>
+          </mc:Choice>
+          <mc:Fallback xmlns="">
+            <p:pic>
+              <p:nvPicPr>
+                <p:cNvPr id="31" name="Ink 30">
+                  <a:extLst>
+                    <a:ext uri="{FF2B5EF4-FFF2-40B4-BE49-F238E27FC236}">
+                      <a16:creationId xmlns:a16="http://schemas.microsoft.com/office/drawing/2014/main" id="{AC59A9D6-A02C-BA25-0F2A-C6289C1C42CD}"/>
+                    </a:ext>
+                  </a:extLst>
+                </p:cNvPr>
+                <p:cNvPicPr/>
+                <p:nvPr/>
+              </p:nvPicPr>
+              <p:blipFill>
+                <a:blip r:embed="rId6"/>
+                <a:stretch>
+                  <a:fillRect/>
+                </a:stretch>
+              </p:blipFill>
+              <p:spPr>
+                <a:xfrm>
+                  <a:off x="2494315" y="3630640"/>
+                  <a:ext cx="196200" cy="69120"/>
+                </a:xfrm>
+                <a:prstGeom prst="rect">
+                  <a:avLst/>
+                </a:prstGeom>
+              </p:spPr>
+            </p:pic>
+          </mc:Fallback>
+        </mc:AlternateContent>
+        <mc:AlternateContent xmlns:mc="http://schemas.openxmlformats.org/markup-compatibility/2006" xmlns:p14="http://schemas.microsoft.com/office/powerpoint/2010/main">
+          <mc:Choice Requires="p14">
+            <p:contentPart p14:bwMode="auto" r:id="rId7">
+              <p14:nvContentPartPr>
+                <p14:cNvPr id="32" name="Ink 31">
+                  <a:extLst>
+                    <a:ext uri="{FF2B5EF4-FFF2-40B4-BE49-F238E27FC236}">
+                      <a16:creationId xmlns:a16="http://schemas.microsoft.com/office/drawing/2014/main" id="{5D22B41C-3679-D881-09B2-C00496BDD018}"/>
+                    </a:ext>
+                  </a:extLst>
+                </p14:cNvPr>
+                <p14:cNvContentPartPr/>
+                <p14:nvPr/>
+              </p14:nvContentPartPr>
+              <p14:xfrm>
+                <a:off x="2505115" y="3477280"/>
+                <a:ext cx="172080" cy="123480"/>
+              </p14:xfrm>
+            </p:contentPart>
+          </mc:Choice>
+          <mc:Fallback xmlns="">
+            <p:pic>
+              <p:nvPicPr>
+                <p:cNvPr id="32" name="Ink 31">
+                  <a:extLst>
+                    <a:ext uri="{FF2B5EF4-FFF2-40B4-BE49-F238E27FC236}">
+                      <a16:creationId xmlns:a16="http://schemas.microsoft.com/office/drawing/2014/main" id="{5D22B41C-3679-D881-09B2-C00496BDD018}"/>
+                    </a:ext>
+                  </a:extLst>
+                </p:cNvPr>
+                <p:cNvPicPr/>
+                <p:nvPr/>
+              </p:nvPicPr>
+              <p:blipFill>
+                <a:blip r:embed="rId8"/>
+                <a:stretch>
+                  <a:fillRect/>
+                </a:stretch>
+              </p:blipFill>
+              <p:spPr>
+                <a:xfrm>
+                  <a:off x="2498995" y="3471160"/>
+                  <a:ext cx="184320" cy="135720"/>
+                </a:xfrm>
+                <a:prstGeom prst="rect">
+                  <a:avLst/>
+                </a:prstGeom>
+              </p:spPr>
+            </p:pic>
+          </mc:Fallback>
+        </mc:AlternateContent>
+        <mc:AlternateContent xmlns:mc="http://schemas.openxmlformats.org/markup-compatibility/2006" xmlns:p14="http://schemas.microsoft.com/office/powerpoint/2010/main">
+          <mc:Choice Requires="p14">
+            <p:contentPart p14:bwMode="auto" r:id="rId9">
+              <p14:nvContentPartPr>
+                <p14:cNvPr id="35" name="Ink 34">
+                  <a:extLst>
+                    <a:ext uri="{FF2B5EF4-FFF2-40B4-BE49-F238E27FC236}">
+                      <a16:creationId xmlns:a16="http://schemas.microsoft.com/office/drawing/2014/main" id="{F74D41D8-5D9A-7FDF-EF98-03E1A1B7D2D6}"/>
+                    </a:ext>
+                  </a:extLst>
+                </p14:cNvPr>
+                <p14:cNvContentPartPr/>
+                <p14:nvPr/>
+              </p14:nvContentPartPr>
+              <p14:xfrm>
+                <a:off x="2520955" y="3336520"/>
+                <a:ext cx="124560" cy="116640"/>
+              </p14:xfrm>
+            </p:contentPart>
+          </mc:Choice>
+          <mc:Fallback xmlns="">
+            <p:pic>
+              <p:nvPicPr>
+                <p:cNvPr id="35" name="Ink 34">
+                  <a:extLst>
+                    <a:ext uri="{FF2B5EF4-FFF2-40B4-BE49-F238E27FC236}">
+                      <a16:creationId xmlns:a16="http://schemas.microsoft.com/office/drawing/2014/main" id="{F74D41D8-5D9A-7FDF-EF98-03E1A1B7D2D6}"/>
+                    </a:ext>
+                  </a:extLst>
+                </p:cNvPr>
+                <p:cNvPicPr/>
+                <p:nvPr/>
+              </p:nvPicPr>
+              <p:blipFill>
+                <a:blip r:embed="rId10"/>
+                <a:stretch>
+                  <a:fillRect/>
+                </a:stretch>
+              </p:blipFill>
+              <p:spPr>
+                <a:xfrm>
+                  <a:off x="2514835" y="3330400"/>
+                  <a:ext cx="136800" cy="128880"/>
+                </a:xfrm>
+                <a:prstGeom prst="rect">
+                  <a:avLst/>
+                </a:prstGeom>
+              </p:spPr>
+            </p:pic>
+          </mc:Fallback>
+        </mc:AlternateContent>
+      </p:grpSp>
+      <mc:AlternateContent xmlns:mc="http://schemas.openxmlformats.org/markup-compatibility/2006" xmlns:p14="http://schemas.microsoft.com/office/powerpoint/2010/main">
+        <mc:Choice Requires="p14">
+          <p:contentPart p14:bwMode="auto" r:id="rId11">
+            <p14:nvContentPartPr>
+              <p14:cNvPr id="45" name="Ink 44">
+                <a:extLst>
+                  <a:ext uri="{FF2B5EF4-FFF2-40B4-BE49-F238E27FC236}">
+                    <a16:creationId xmlns:a16="http://schemas.microsoft.com/office/drawing/2014/main" id="{5EC2E70E-39E2-BBF1-5024-7F843AECC520}"/>
+                  </a:ext>
+                </a:extLst>
+              </p14:cNvPr>
+              <p14:cNvContentPartPr/>
+              <p14:nvPr/>
+            </p14:nvContentPartPr>
+            <p14:xfrm>
+              <a:off x="2441457" y="3780690"/>
+              <a:ext cx="47880" cy="44280"/>
+            </p14:xfrm>
+          </p:contentPart>
+        </mc:Choice>
+        <mc:Fallback xmlns="">
+          <p:pic>
+            <p:nvPicPr>
+              <p:cNvPr id="45" name="Ink 44">
+                <a:extLst>
+                  <a:ext uri="{FF2B5EF4-FFF2-40B4-BE49-F238E27FC236}">
+                    <a16:creationId xmlns:a16="http://schemas.microsoft.com/office/drawing/2014/main" id="{5EC2E70E-39E2-BBF1-5024-7F843AECC520}"/>
+                  </a:ext>
+                </a:extLst>
+              </p:cNvPr>
+              <p:cNvPicPr/>
+              <p:nvPr/>
+            </p:nvPicPr>
+            <p:blipFill>
+              <a:blip r:embed="rId12"/>
+              <a:stretch>
+                <a:fillRect/>
+              </a:stretch>
+            </p:blipFill>
+            <p:spPr>
+              <a:xfrm>
+                <a:off x="2435337" y="3774570"/>
+                <a:ext cx="60120" cy="56520"/>
+              </a:xfrm>
+              <a:prstGeom prst="rect">
+                <a:avLst/>
+              </a:prstGeom>
+            </p:spPr>
+          </p:pic>
+        </mc:Fallback>
+      </mc:AlternateContent>
+      <mc:AlternateContent xmlns:mc="http://schemas.openxmlformats.org/markup-compatibility/2006" xmlns:p14="http://schemas.microsoft.com/office/powerpoint/2010/main">
+        <mc:Choice Requires="p14">
+          <p:contentPart p14:bwMode="auto" r:id="rId13">
+            <p14:nvContentPartPr>
+              <p14:cNvPr id="46" name="Ink 45">
+                <a:extLst>
+                  <a:ext uri="{FF2B5EF4-FFF2-40B4-BE49-F238E27FC236}">
+                    <a16:creationId xmlns:a16="http://schemas.microsoft.com/office/drawing/2014/main" id="{FBE3FACF-9166-89DF-AD43-2E2B52240F3E}"/>
+                  </a:ext>
+                </a:extLst>
+              </p14:cNvPr>
+              <p14:cNvContentPartPr/>
+              <p14:nvPr/>
+            </p14:nvContentPartPr>
+            <p14:xfrm>
+              <a:off x="2431737" y="3877890"/>
+              <a:ext cx="360" cy="360"/>
+            </p14:xfrm>
+          </p:contentPart>
+        </mc:Choice>
+        <mc:Fallback xmlns="">
+          <p:pic>
+            <p:nvPicPr>
+              <p:cNvPr id="46" name="Ink 45">
+                <a:extLst>
+                  <a:ext uri="{FF2B5EF4-FFF2-40B4-BE49-F238E27FC236}">
+                    <a16:creationId xmlns:a16="http://schemas.microsoft.com/office/drawing/2014/main" id="{FBE3FACF-9166-89DF-AD43-2E2B52240F3E}"/>
+                  </a:ext>
+                </a:extLst>
+              </p:cNvPr>
+              <p:cNvPicPr/>
+              <p:nvPr/>
+            </p:nvPicPr>
+            <p:blipFill>
+              <a:blip r:embed="rId14"/>
+              <a:stretch>
+                <a:fillRect/>
+              </a:stretch>
+            </p:blipFill>
+            <p:spPr>
+              <a:xfrm>
+                <a:off x="2425617" y="3871770"/>
+                <a:ext cx="12600" cy="12600"/>
+              </a:xfrm>
+              <a:prstGeom prst="rect">
+                <a:avLst/>
+              </a:prstGeom>
+            </p:spPr>
+          </p:pic>
+        </mc:Fallback>
+      </mc:AlternateContent>
+      <mc:AlternateContent xmlns:mc="http://schemas.openxmlformats.org/markup-compatibility/2006" xmlns:p14="http://schemas.microsoft.com/office/powerpoint/2010/main">
+        <mc:Choice Requires="p14">
+          <p:contentPart p14:bwMode="auto" r:id="rId15">
+            <p14:nvContentPartPr>
+              <p14:cNvPr id="47" name="Ink 46">
+                <a:extLst>
+                  <a:ext uri="{FF2B5EF4-FFF2-40B4-BE49-F238E27FC236}">
+                    <a16:creationId xmlns:a16="http://schemas.microsoft.com/office/drawing/2014/main" id="{53292806-0F8D-5C72-970B-A9EA46734586}"/>
+                  </a:ext>
+                </a:extLst>
+              </p14:cNvPr>
+              <p14:cNvContentPartPr/>
+              <p14:nvPr/>
+            </p14:nvContentPartPr>
+            <p14:xfrm>
+              <a:off x="2849697" y="3810210"/>
+              <a:ext cx="360" cy="360"/>
+            </p14:xfrm>
+          </p:contentPart>
+        </mc:Choice>
+        <mc:Fallback xmlns="">
+          <p:pic>
+            <p:nvPicPr>
+              <p:cNvPr id="47" name="Ink 46">
+                <a:extLst>
+                  <a:ext uri="{FF2B5EF4-FFF2-40B4-BE49-F238E27FC236}">
+                    <a16:creationId xmlns:a16="http://schemas.microsoft.com/office/drawing/2014/main" id="{53292806-0F8D-5C72-970B-A9EA46734586}"/>
+                  </a:ext>
+                </a:extLst>
+              </p:cNvPr>
+              <p:cNvPicPr/>
+              <p:nvPr/>
+            </p:nvPicPr>
+            <p:blipFill>
+              <a:blip r:embed="rId14"/>
+              <a:stretch>
+                <a:fillRect/>
+              </a:stretch>
+            </p:blipFill>
+            <p:spPr>
+              <a:xfrm>
+                <a:off x="2843577" y="3804090"/>
+                <a:ext cx="12600" cy="12600"/>
+              </a:xfrm>
+              <a:prstGeom prst="rect">
+                <a:avLst/>
+              </a:prstGeom>
+            </p:spPr>
+          </p:pic>
+        </mc:Fallback>
+      </mc:AlternateContent>
+      <p:cxnSp>
+        <p:nvCxnSpPr>
+          <p:cNvPr id="72" name="Straight Arrow Connector 71">
+            <a:extLst>
+              <a:ext uri="{FF2B5EF4-FFF2-40B4-BE49-F238E27FC236}">
+                <a16:creationId xmlns:a16="http://schemas.microsoft.com/office/drawing/2014/main" id="{717852B9-A58E-73F6-9E9D-14C114C8495C}"/>
+              </a:ext>
+            </a:extLst>
+          </p:cNvPr>
+          <p:cNvCxnSpPr/>
+          <p:nvPr/>
+        </p:nvCxnSpPr>
+        <p:spPr>
+          <a:xfrm>
+            <a:off x="2403949" y="1924115"/>
+            <a:ext cx="299575" cy="0"/>
+          </a:xfrm>
+          <a:prstGeom prst="straightConnector1">
+            <a:avLst/>
+          </a:prstGeom>
+          <a:ln>
+            <a:headEnd type="triangle"/>
+            <a:tailEnd type="triangle"/>
+          </a:ln>
+        </p:spPr>
+        <p:style>
+          <a:lnRef idx="2">
+            <a:schemeClr val="dk1"/>
+          </a:lnRef>
+          <a:fillRef idx="0">
+            <a:schemeClr val="dk1"/>
+          </a:fillRef>
+          <a:effectRef idx="1">
+            <a:schemeClr val="dk1"/>
+          </a:effectRef>
+          <a:fontRef idx="minor">
+            <a:schemeClr val="tx1"/>
+          </a:fontRef>
+        </p:style>
+      </p:cxnSp>
+      <mc:AlternateContent xmlns:mc="http://schemas.openxmlformats.org/markup-compatibility/2006" xmlns:a14="http://schemas.microsoft.com/office/drawing/2010/main">
+        <mc:Choice Requires="a14">
+          <p:sp>
+            <p:nvSpPr>
+              <p:cNvPr id="73" name="TextBox 72">
+                <a:extLst>
+                  <a:ext uri="{FF2B5EF4-FFF2-40B4-BE49-F238E27FC236}">
+                    <a16:creationId xmlns:a16="http://schemas.microsoft.com/office/drawing/2014/main" id="{4C476120-C50F-6ADB-CF11-0D551CC5CD7E}"/>
+                  </a:ext>
+                </a:extLst>
+              </p:cNvPr>
+              <p:cNvSpPr txBox="1"/>
+              <p:nvPr/>
+            </p:nvSpPr>
+            <p:spPr>
+              <a:xfrm>
+                <a:off x="2154305" y="1563678"/>
+                <a:ext cx="817827" cy="338554"/>
+              </a:xfrm>
+              <a:prstGeom prst="rect">
+                <a:avLst/>
+              </a:prstGeom>
+              <a:noFill/>
+            </p:spPr>
+            <p:txBody>
+              <a:bodyPr wrap="square" rtlCol="0">
+                <a:spAutoFit/>
+              </a:bodyPr>
+              <a:lstStyle/>
+              <a:p>
+                <a:pPr/>
+                <a14:m>
+                  <m:oMathPara xmlns:m="http://schemas.openxmlformats.org/officeDocument/2006/math">
+                    <m:oMathParaPr>
+                      <m:jc m:val="centerGroup"/>
+                    </m:oMathParaPr>
+                    <m:oMath xmlns:m="http://schemas.openxmlformats.org/officeDocument/2006/math">
+                      <m:r>
+                        <m:rPr>
+                          <m:sty m:val="p"/>
+                        </m:rPr>
+                        <a:rPr lang="en-US" sz="1600" b="0" i="1" smtClean="0">
+                          <a:latin typeface="Cambria Math" panose="02040503050406030204" pitchFamily="18" charset="0"/>
+                        </a:rPr>
+                        <m:t>Δ</m:t>
+                      </m:r>
+                    </m:oMath>
+                  </m:oMathPara>
+                </a14:m>
+                <a:endParaRPr lang="en-US" sz="1600" b="0" dirty="0"/>
+              </a:p>
+            </p:txBody>
+          </p:sp>
+        </mc:Choice>
+        <mc:Fallback xmlns="">
+          <p:sp>
+            <p:nvSpPr>
+              <p:cNvPr id="73" name="TextBox 72">
+                <a:extLst>
+                  <a:ext uri="{FF2B5EF4-FFF2-40B4-BE49-F238E27FC236}">
+                    <a16:creationId xmlns:a16="http://schemas.microsoft.com/office/drawing/2014/main" id="{4C476120-C50F-6ADB-CF11-0D551CC5CD7E}"/>
+                  </a:ext>
+                </a:extLst>
+              </p:cNvPr>
+              <p:cNvSpPr txBox="1">
+                <a:spLocks noRot="1" noChangeAspect="1" noMove="1" noResize="1" noEditPoints="1" noAdjustHandles="1" noChangeArrowheads="1" noChangeShapeType="1" noTextEdit="1"/>
+              </p:cNvSpPr>
+              <p:nvPr/>
+            </p:nvSpPr>
+            <p:spPr>
+              <a:xfrm>
+                <a:off x="2154305" y="1563678"/>
+                <a:ext cx="817827" cy="338554"/>
+              </a:xfrm>
+              <a:prstGeom prst="rect">
+                <a:avLst/>
+              </a:prstGeom>
+              <a:blipFill>
+                <a:blip r:embed="rId16"/>
+                <a:stretch>
+                  <a:fillRect/>
+                </a:stretch>
+              </a:blipFill>
+            </p:spPr>
+            <p:txBody>
+              <a:bodyPr/>
+              <a:lstStyle/>
+              <a:p>
+                <a:r>
+                  <a:rPr lang="en-US">
+                    <a:noFill/>
+                  </a:rPr>
+                  <a:t> </a:t>
+                </a:r>
+              </a:p>
+            </p:txBody>
+          </p:sp>
+        </mc:Fallback>
+      </mc:AlternateContent>
+      <mc:AlternateContent xmlns:mc="http://schemas.openxmlformats.org/markup-compatibility/2006" xmlns:a14="http://schemas.microsoft.com/office/drawing/2010/main">
+        <mc:Choice Requires="a14">
+          <p:sp>
+            <p:nvSpPr>
+              <p:cNvPr id="74" name="TextBox 73">
+                <a:extLst>
+                  <a:ext uri="{FF2B5EF4-FFF2-40B4-BE49-F238E27FC236}">
+                    <a16:creationId xmlns:a16="http://schemas.microsoft.com/office/drawing/2014/main" id="{5AFE5064-969F-A6F4-B4D2-E99C5BF5CEB4}"/>
+                  </a:ext>
+                </a:extLst>
+              </p:cNvPr>
+              <p:cNvSpPr txBox="1"/>
+              <p:nvPr/>
+            </p:nvSpPr>
+            <p:spPr>
+              <a:xfrm>
+                <a:off x="4160677" y="1555070"/>
+                <a:ext cx="659473" cy="357534"/>
+              </a:xfrm>
+              <a:prstGeom prst="rect">
+                <a:avLst/>
+              </a:prstGeom>
+              <a:noFill/>
+            </p:spPr>
+            <p:txBody>
+              <a:bodyPr wrap="square" rtlCol="0">
+                <a:spAutoFit/>
+              </a:bodyPr>
+              <a:lstStyle/>
+              <a:p>
+                <a:pPr/>
+                <a14:m>
+                  <m:oMathPara xmlns:m="http://schemas.openxmlformats.org/officeDocument/2006/math">
+                    <m:oMathParaPr>
+                      <m:jc m:val="centerGroup"/>
+                    </m:oMathParaPr>
+                    <m:oMath xmlns:m="http://schemas.openxmlformats.org/officeDocument/2006/math">
+                      <m:sSub>
+                        <m:sSubPr>
+                          <m:ctrlPr>
+                            <a:rPr lang="en-US" sz="1600" b="0" i="1" smtClean="0">
+                              <a:latin typeface="Cambria Math" panose="02040503050406030204" pitchFamily="18" charset="0"/>
+                            </a:rPr>
+                          </m:ctrlPr>
+                        </m:sSubPr>
+                        <m:e>
+                          <m:r>
+                            <m:rPr>
+                              <m:sty m:val="p"/>
+                            </m:rPr>
+                            <a:rPr lang="en-US" sz="1600" b="0" i="1" smtClean="0">
+                              <a:latin typeface="Cambria Math" panose="02040503050406030204" pitchFamily="18" charset="0"/>
+                            </a:rPr>
+                            <m:t>Δ</m:t>
+                          </m:r>
+                        </m:e>
+                        <m:sub>
+                          <m:r>
+                            <a:rPr lang="en-US" sz="1600" b="0" i="1" smtClean="0">
+                              <a:latin typeface="Cambria Math" panose="02040503050406030204" pitchFamily="18" charset="0"/>
+                            </a:rPr>
+                            <m:t>𝑝</m:t>
+                          </m:r>
+                        </m:sub>
+                      </m:sSub>
+                    </m:oMath>
+                  </m:oMathPara>
+                </a14:m>
+                <a:endParaRPr lang="en-US" sz="1600" b="0" dirty="0"/>
+              </a:p>
+            </p:txBody>
+          </p:sp>
+        </mc:Choice>
+        <mc:Fallback xmlns="">
+          <p:sp>
+            <p:nvSpPr>
+              <p:cNvPr id="74" name="TextBox 73">
+                <a:extLst>
+                  <a:ext uri="{FF2B5EF4-FFF2-40B4-BE49-F238E27FC236}">
+                    <a16:creationId xmlns:a16="http://schemas.microsoft.com/office/drawing/2014/main" id="{5AFE5064-969F-A6F4-B4D2-E99C5BF5CEB4}"/>
+                  </a:ext>
+                </a:extLst>
+              </p:cNvPr>
+              <p:cNvSpPr txBox="1">
+                <a:spLocks noRot="1" noChangeAspect="1" noMove="1" noResize="1" noEditPoints="1" noAdjustHandles="1" noChangeArrowheads="1" noChangeShapeType="1" noTextEdit="1"/>
+              </p:cNvSpPr>
+              <p:nvPr/>
+            </p:nvSpPr>
+            <p:spPr>
+              <a:xfrm>
+                <a:off x="4160677" y="1555070"/>
+                <a:ext cx="659473" cy="357534"/>
+              </a:xfrm>
+              <a:prstGeom prst="rect">
+                <a:avLst/>
+              </a:prstGeom>
+              <a:blipFill>
+                <a:blip r:embed="rId17"/>
+                <a:stretch>
+                  <a:fillRect/>
+                </a:stretch>
+              </a:blipFill>
+            </p:spPr>
+            <p:txBody>
+              <a:bodyPr/>
+              <a:lstStyle/>
+              <a:p>
+                <a:r>
+                  <a:rPr lang="en-US">
+                    <a:noFill/>
+                  </a:rPr>
+                  <a:t> </a:t>
+                </a:r>
+              </a:p>
+            </p:txBody>
+          </p:sp>
+        </mc:Fallback>
+      </mc:AlternateContent>
+      <mc:AlternateContent xmlns:mc="http://schemas.openxmlformats.org/markup-compatibility/2006" xmlns:a14="http://schemas.microsoft.com/office/drawing/2010/main">
+        <mc:Choice Requires="a14">
+          <p:sp>
+            <p:nvSpPr>
+              <p:cNvPr id="75" name="TextBox 74">
+                <a:extLst>
+                  <a:ext uri="{FF2B5EF4-FFF2-40B4-BE49-F238E27FC236}">
+                    <a16:creationId xmlns:a16="http://schemas.microsoft.com/office/drawing/2014/main" id="{287F52A1-97CB-492A-86E8-A4D9247BCB92}"/>
+                  </a:ext>
+                </a:extLst>
+              </p:cNvPr>
+              <p:cNvSpPr txBox="1"/>
+              <p:nvPr/>
+            </p:nvSpPr>
+            <p:spPr>
+              <a:xfrm>
+                <a:off x="4570738" y="1551841"/>
+                <a:ext cx="817827" cy="338554"/>
+              </a:xfrm>
+              <a:prstGeom prst="rect">
+                <a:avLst/>
+              </a:prstGeom>
+              <a:noFill/>
+            </p:spPr>
+            <p:txBody>
+              <a:bodyPr wrap="square" rtlCol="0">
+                <a:spAutoFit/>
+              </a:bodyPr>
+              <a:lstStyle/>
+              <a:p>
+                <a:pPr/>
+                <a14:m>
+                  <m:oMathPara xmlns:m="http://schemas.openxmlformats.org/officeDocument/2006/math">
+                    <m:oMathParaPr>
+                      <m:jc m:val="centerGroup"/>
+                    </m:oMathParaPr>
+                    <m:oMath xmlns:m="http://schemas.openxmlformats.org/officeDocument/2006/math">
+                      <m:sSub>
+                        <m:sSubPr>
+                          <m:ctrlPr>
+                            <a:rPr lang="en-US" sz="1600" b="0" i="1" smtClean="0">
+                              <a:latin typeface="Cambria Math" panose="02040503050406030204" pitchFamily="18" charset="0"/>
+                            </a:rPr>
+                          </m:ctrlPr>
+                        </m:sSubPr>
+                        <m:e>
+                          <m:r>
+                            <m:rPr>
+                              <m:sty m:val="p"/>
+                            </m:rPr>
+                            <a:rPr lang="en-US" sz="1600" b="0" i="1" smtClean="0">
+                              <a:latin typeface="Cambria Math" panose="02040503050406030204" pitchFamily="18" charset="0"/>
+                            </a:rPr>
+                            <m:t>Δ</m:t>
+                          </m:r>
+                        </m:e>
+                        <m:sub>
+                          <m:r>
+                            <a:rPr lang="en-US" sz="1600" b="0" i="1" smtClean="0">
+                              <a:latin typeface="Cambria Math" panose="02040503050406030204" pitchFamily="18" charset="0"/>
+                            </a:rPr>
+                            <m:t>𝑒𝑙</m:t>
+                          </m:r>
+                        </m:sub>
+                      </m:sSub>
+                    </m:oMath>
+                  </m:oMathPara>
+                </a14:m>
+                <a:endParaRPr lang="en-US" sz="1600" b="0" dirty="0"/>
+              </a:p>
+            </p:txBody>
+          </p:sp>
+        </mc:Choice>
+        <mc:Fallback xmlns="">
+          <p:sp>
+            <p:nvSpPr>
+              <p:cNvPr id="75" name="TextBox 74">
+                <a:extLst>
+                  <a:ext uri="{FF2B5EF4-FFF2-40B4-BE49-F238E27FC236}">
+                    <a16:creationId xmlns:a16="http://schemas.microsoft.com/office/drawing/2014/main" id="{287F52A1-97CB-492A-86E8-A4D9247BCB92}"/>
+                  </a:ext>
+                </a:extLst>
+              </p:cNvPr>
+              <p:cNvSpPr txBox="1">
+                <a:spLocks noRot="1" noChangeAspect="1" noMove="1" noResize="1" noEditPoints="1" noAdjustHandles="1" noChangeArrowheads="1" noChangeShapeType="1" noTextEdit="1"/>
+              </p:cNvSpPr>
+              <p:nvPr/>
+            </p:nvSpPr>
+            <p:spPr>
+              <a:xfrm>
+                <a:off x="4570738" y="1551841"/>
+                <a:ext cx="817827" cy="338554"/>
+              </a:xfrm>
+              <a:prstGeom prst="rect">
+                <a:avLst/>
+              </a:prstGeom>
+              <a:blipFill>
+                <a:blip r:embed="rId18"/>
+                <a:stretch>
+                  <a:fillRect/>
+                </a:stretch>
+              </a:blipFill>
+            </p:spPr>
+            <p:txBody>
+              <a:bodyPr/>
+              <a:lstStyle/>
+              <a:p>
+                <a:r>
+                  <a:rPr lang="en-US">
+                    <a:noFill/>
+                  </a:rPr>
+                  <a:t> </a:t>
+                </a:r>
+              </a:p>
+            </p:txBody>
+          </p:sp>
+        </mc:Fallback>
+      </mc:AlternateContent>
+      <p:cxnSp>
+        <p:nvCxnSpPr>
+          <p:cNvPr id="76" name="Straight Arrow Connector 75">
+            <a:extLst>
+              <a:ext uri="{FF2B5EF4-FFF2-40B4-BE49-F238E27FC236}">
+                <a16:creationId xmlns:a16="http://schemas.microsoft.com/office/drawing/2014/main" id="{27F22EA1-9AF6-847D-0C5B-8CCC497A7962}"/>
+              </a:ext>
+            </a:extLst>
+          </p:cNvPr>
+          <p:cNvCxnSpPr>
+            <a:cxnSpLocks/>
+          </p:cNvCxnSpPr>
+          <p:nvPr/>
+        </p:nvCxnSpPr>
+        <p:spPr>
+          <a:xfrm>
+            <a:off x="4160677" y="1941826"/>
+            <a:ext cx="640572" cy="0"/>
+          </a:xfrm>
+          <a:prstGeom prst="straightConnector1">
+            <a:avLst/>
+          </a:prstGeom>
+          <a:ln>
+            <a:headEnd type="triangle"/>
+            <a:tailEnd type="triangle"/>
+          </a:ln>
+        </p:spPr>
+        <p:style>
+          <a:lnRef idx="2">
+            <a:schemeClr val="dk1"/>
+          </a:lnRef>
+          <a:fillRef idx="0">
+            <a:schemeClr val="dk1"/>
+          </a:fillRef>
+          <a:effectRef idx="1">
+            <a:schemeClr val="dk1"/>
+          </a:effectRef>
+          <a:fontRef idx="minor">
+            <a:schemeClr val="tx1"/>
+          </a:fontRef>
+        </p:style>
+      </p:cxnSp>
+      <p:cxnSp>
+        <p:nvCxnSpPr>
+          <p:cNvPr id="83" name="Straight Arrow Connector 82">
+            <a:extLst>
+              <a:ext uri="{FF2B5EF4-FFF2-40B4-BE49-F238E27FC236}">
+                <a16:creationId xmlns:a16="http://schemas.microsoft.com/office/drawing/2014/main" id="{5E2FED81-3759-DAEE-30EB-8C69AEBAA420}"/>
+              </a:ext>
+            </a:extLst>
+          </p:cNvPr>
+          <p:cNvCxnSpPr>
+            <a:cxnSpLocks/>
+          </p:cNvCxnSpPr>
+          <p:nvPr/>
+        </p:nvCxnSpPr>
+        <p:spPr>
+          <a:xfrm>
+            <a:off x="4807226" y="1938596"/>
+            <a:ext cx="344853" cy="0"/>
+          </a:xfrm>
+          <a:prstGeom prst="straightConnector1">
+            <a:avLst/>
+          </a:prstGeom>
+          <a:ln>
+            <a:headEnd type="triangle"/>
+            <a:tailEnd type="triangle"/>
+          </a:ln>
+        </p:spPr>
+        <p:style>
+          <a:lnRef idx="2">
+            <a:schemeClr val="dk1"/>
+          </a:lnRef>
+          <a:fillRef idx="0">
+            <a:schemeClr val="dk1"/>
+          </a:fillRef>
+          <a:effectRef idx="1">
+            <a:schemeClr val="dk1"/>
+          </a:effectRef>
+          <a:fontRef idx="minor">
+            <a:schemeClr val="tx1"/>
+          </a:fontRef>
+        </p:style>
+      </p:cxnSp>
+      <mc:AlternateContent xmlns:mc="http://schemas.openxmlformats.org/markup-compatibility/2006" xmlns:a14="http://schemas.microsoft.com/office/drawing/2010/main">
+        <mc:Choice Requires="a14">
+          <p:sp>
+            <p:nvSpPr>
+              <p:cNvPr id="85" name="TextBox 84">
+                <a:extLst>
+                  <a:ext uri="{FF2B5EF4-FFF2-40B4-BE49-F238E27FC236}">
+                    <a16:creationId xmlns:a16="http://schemas.microsoft.com/office/drawing/2014/main" id="{2109C55F-F75E-BADA-A9DA-4DB0F836F45C}"/>
+                  </a:ext>
+                </a:extLst>
+              </p:cNvPr>
+              <p:cNvSpPr txBox="1"/>
+              <p:nvPr/>
+            </p:nvSpPr>
+            <p:spPr>
+              <a:xfrm>
+                <a:off x="4195644" y="3954429"/>
+                <a:ext cx="659473" cy="357534"/>
+              </a:xfrm>
+              <a:prstGeom prst="rect">
+                <a:avLst/>
+              </a:prstGeom>
+              <a:noFill/>
+            </p:spPr>
+            <p:txBody>
+              <a:bodyPr wrap="square" rtlCol="0">
+                <a:spAutoFit/>
+              </a:bodyPr>
+              <a:lstStyle/>
+              <a:p>
+                <a:pPr/>
+                <a14:m>
+                  <m:oMathPara xmlns:m="http://schemas.openxmlformats.org/officeDocument/2006/math">
+                    <m:oMathParaPr>
+                      <m:jc m:val="centerGroup"/>
+                    </m:oMathParaPr>
+                    <m:oMath xmlns:m="http://schemas.openxmlformats.org/officeDocument/2006/math">
+                      <m:sSub>
+                        <m:sSubPr>
+                          <m:ctrlPr>
+                            <a:rPr lang="en-US" sz="1600" b="0" i="1" smtClean="0">
+                              <a:latin typeface="Cambria Math" panose="02040503050406030204" pitchFamily="18" charset="0"/>
+                            </a:rPr>
+                          </m:ctrlPr>
+                        </m:sSubPr>
+                        <m:e>
+                          <m:r>
+                            <a:rPr lang="en-US" sz="1600" b="0" i="1" smtClean="0">
+                              <a:latin typeface="Cambria Math" panose="02040503050406030204" pitchFamily="18" charset="0"/>
+                            </a:rPr>
+                            <m:t>𝜃</m:t>
+                          </m:r>
+                        </m:e>
+                        <m:sub>
+                          <m:r>
+                            <a:rPr lang="en-US" sz="1600" b="0" i="1" smtClean="0">
+                              <a:latin typeface="Cambria Math" panose="02040503050406030204" pitchFamily="18" charset="0"/>
+                            </a:rPr>
+                            <m:t>𝑝</m:t>
+                          </m:r>
+                        </m:sub>
+                      </m:sSub>
+                    </m:oMath>
+                  </m:oMathPara>
+                </a14:m>
+                <a:endParaRPr lang="en-US" sz="1600" b="0" dirty="0"/>
+              </a:p>
+            </p:txBody>
+          </p:sp>
+        </mc:Choice>
+        <mc:Fallback xmlns="">
+          <p:sp>
+            <p:nvSpPr>
+              <p:cNvPr id="85" name="TextBox 84">
+                <a:extLst>
+                  <a:ext uri="{FF2B5EF4-FFF2-40B4-BE49-F238E27FC236}">
+                    <a16:creationId xmlns:a16="http://schemas.microsoft.com/office/drawing/2014/main" id="{2109C55F-F75E-BADA-A9DA-4DB0F836F45C}"/>
+                  </a:ext>
+                </a:extLst>
+              </p:cNvPr>
+              <p:cNvSpPr txBox="1">
+                <a:spLocks noRot="1" noChangeAspect="1" noMove="1" noResize="1" noEditPoints="1" noAdjustHandles="1" noChangeArrowheads="1" noChangeShapeType="1" noTextEdit="1"/>
+              </p:cNvSpPr>
+              <p:nvPr/>
+            </p:nvSpPr>
+            <p:spPr>
+              <a:xfrm>
+                <a:off x="4195644" y="3954429"/>
+                <a:ext cx="659473" cy="357534"/>
+              </a:xfrm>
+              <a:prstGeom prst="rect">
+                <a:avLst/>
+              </a:prstGeom>
+              <a:blipFill>
+                <a:blip r:embed="rId19"/>
+                <a:stretch>
+                  <a:fillRect/>
+                </a:stretch>
+              </a:blipFill>
+            </p:spPr>
+            <p:txBody>
+              <a:bodyPr/>
+              <a:lstStyle/>
+              <a:p>
+                <a:r>
+                  <a:rPr lang="en-US">
+                    <a:noFill/>
+                  </a:rPr>
+                  <a:t> </a:t>
+                </a:r>
+              </a:p>
+            </p:txBody>
+          </p:sp>
+        </mc:Fallback>
+      </mc:AlternateContent>
+      <p:sp>
+        <p:nvSpPr>
+          <p:cNvPr id="86" name="Arc 85">
+            <a:extLst>
+              <a:ext uri="{FF2B5EF4-FFF2-40B4-BE49-F238E27FC236}">
+                <a16:creationId xmlns:a16="http://schemas.microsoft.com/office/drawing/2014/main" id="{A58B6A96-C871-0146-8F13-7E8B7EF1F16A}"/>
+              </a:ext>
+            </a:extLst>
+          </p:cNvPr>
+          <p:cNvSpPr/>
+          <p:nvPr/>
+        </p:nvSpPr>
+        <p:spPr>
+          <a:xfrm rot="2051384">
+            <a:off x="3955865" y="3958395"/>
+            <a:ext cx="420853" cy="382012"/>
+          </a:xfrm>
+          <a:prstGeom prst="arc">
+            <a:avLst>
+              <a:gd name="adj1" fmla="val 10272888"/>
+              <a:gd name="adj2" fmla="val 13976862"/>
+            </a:avLst>
+          </a:prstGeom>
+          <a:ln>
+            <a:solidFill>
+              <a:schemeClr val="tx1"/>
+            </a:solidFill>
+            <a:headEnd type="none" w="med" len="med"/>
+            <a:tailEnd type="triangle" w="med" len="med"/>
+          </a:ln>
+        </p:spPr>
+        <p:style>
+          <a:lnRef idx="2">
+            <a:schemeClr val="dk1"/>
+          </a:lnRef>
+          <a:fillRef idx="0">
+            <a:schemeClr val="dk1"/>
+          </a:fillRef>
+          <a:effectRef idx="1">
+            <a:schemeClr val="dk1"/>
+          </a:effectRef>
+          <a:fontRef idx="minor">
+            <a:schemeClr val="tx1"/>
+          </a:fontRef>
+        </p:style>
+        <p:txBody>
+          <a:bodyPr rtlCol="0" anchor="ctr"/>
+          <a:lstStyle/>
+          <a:p>
+            <a:pPr algn="ctr"/>
+            <a:endParaRPr lang="en-US"/>
+          </a:p>
+        </p:txBody>
+      </p:sp>
+      <p:sp>
+        <p:nvSpPr>
+          <p:cNvPr id="87" name="Arc 86">
+            <a:extLst>
+              <a:ext uri="{FF2B5EF4-FFF2-40B4-BE49-F238E27FC236}">
+                <a16:creationId xmlns:a16="http://schemas.microsoft.com/office/drawing/2014/main" id="{2D3466F1-271C-716E-B7A0-19B73475BFB5}"/>
+              </a:ext>
+            </a:extLst>
+          </p:cNvPr>
+          <p:cNvSpPr/>
+          <p:nvPr/>
+        </p:nvSpPr>
+        <p:spPr>
+          <a:xfrm rot="2051384">
+            <a:off x="3950516" y="3956023"/>
+            <a:ext cx="420853" cy="382012"/>
+          </a:xfrm>
+          <a:prstGeom prst="arc">
+            <a:avLst>
+              <a:gd name="adj1" fmla="val 16265848"/>
+              <a:gd name="adj2" fmla="val 20050059"/>
+            </a:avLst>
+          </a:prstGeom>
+          <a:ln>
+            <a:solidFill>
+              <a:schemeClr val="tx1"/>
+            </a:solidFill>
+            <a:headEnd type="triangle" w="med" len="med"/>
+            <a:tailEnd type="none" w="med" len="med"/>
+          </a:ln>
+        </p:spPr>
+        <p:style>
+          <a:lnRef idx="2">
+            <a:schemeClr val="dk1"/>
+          </a:lnRef>
+          <a:fillRef idx="0">
+            <a:schemeClr val="dk1"/>
+          </a:fillRef>
+          <a:effectRef idx="1">
+            <a:schemeClr val="dk1"/>
+          </a:effectRef>
+          <a:fontRef idx="minor">
+            <a:schemeClr val="tx1"/>
+          </a:fontRef>
+        </p:style>
+        <p:txBody>
+          <a:bodyPr rtlCol="0" anchor="ctr"/>
+          <a:lstStyle/>
+          <a:p>
+            <a:pPr algn="ctr"/>
+            <a:endParaRPr lang="en-US"/>
+          </a:p>
+        </p:txBody>
+      </p:sp>
+      <p:cxnSp>
+        <p:nvCxnSpPr>
+          <p:cNvPr id="89" name="Straight Arrow Connector 88">
+            <a:extLst>
+              <a:ext uri="{FF2B5EF4-FFF2-40B4-BE49-F238E27FC236}">
+                <a16:creationId xmlns:a16="http://schemas.microsoft.com/office/drawing/2014/main" id="{88ED97EF-5E9C-A4F8-EF68-7F13A56E477E}"/>
+              </a:ext>
+            </a:extLst>
+          </p:cNvPr>
+          <p:cNvCxnSpPr>
+            <a:cxnSpLocks/>
+          </p:cNvCxnSpPr>
+          <p:nvPr/>
+        </p:nvCxnSpPr>
+        <p:spPr>
+          <a:xfrm>
+            <a:off x="1990343" y="2067069"/>
+            <a:ext cx="346842" cy="0"/>
+          </a:xfrm>
+          <a:prstGeom prst="straightConnector1">
+            <a:avLst/>
+          </a:prstGeom>
+          <a:ln w="38100">
+            <a:solidFill>
+              <a:srgbClr val="FF0000"/>
+            </a:solidFill>
+            <a:tailEnd type="triangle"/>
+          </a:ln>
+        </p:spPr>
+        <p:style>
+          <a:lnRef idx="2">
+            <a:schemeClr val="accent1"/>
+          </a:lnRef>
+          <a:fillRef idx="0">
+            <a:schemeClr val="accent1"/>
+          </a:fillRef>
+          <a:effectRef idx="1">
+            <a:schemeClr val="accent1"/>
+          </a:effectRef>
+          <a:fontRef idx="minor">
+            <a:schemeClr val="tx1"/>
+          </a:fontRef>
+        </p:style>
+      </p:cxnSp>
+      <mc:AlternateContent xmlns:mc="http://schemas.openxmlformats.org/markup-compatibility/2006" xmlns:a14="http://schemas.microsoft.com/office/drawing/2010/main">
+        <mc:Choice Requires="a14">
+          <p:sp>
+            <p:nvSpPr>
+              <p:cNvPr id="91" name="TextBox 90">
+                <a:extLst>
+                  <a:ext uri="{FF2B5EF4-FFF2-40B4-BE49-F238E27FC236}">
+                    <a16:creationId xmlns:a16="http://schemas.microsoft.com/office/drawing/2014/main" id="{13ADCA3B-7E51-A633-1C93-C3D05BC4C7C0}"/>
+                  </a:ext>
+                </a:extLst>
+              </p:cNvPr>
+              <p:cNvSpPr txBox="1"/>
+              <p:nvPr/>
+            </p:nvSpPr>
+            <p:spPr>
+              <a:xfrm>
+                <a:off x="1566753" y="1897792"/>
+                <a:ext cx="502681" cy="338554"/>
+              </a:xfrm>
+              <a:prstGeom prst="rect">
+                <a:avLst/>
+              </a:prstGeom>
+              <a:noFill/>
+            </p:spPr>
+            <p:txBody>
+              <a:bodyPr wrap="square" rtlCol="0">
+                <a:spAutoFit/>
+              </a:bodyPr>
+              <a:lstStyle/>
+              <a:p>
+                <a:pPr/>
+                <a14:m>
+                  <m:oMathPara xmlns:m="http://schemas.openxmlformats.org/officeDocument/2006/math">
+                    <m:oMathParaPr>
+                      <m:jc m:val="centerGroup"/>
+                    </m:oMathParaPr>
+                    <m:oMath xmlns:m="http://schemas.openxmlformats.org/officeDocument/2006/math">
+                      <m:r>
+                        <a:rPr lang="en-US" sz="1600" b="0" i="1" smtClean="0">
+                          <a:latin typeface="Cambria Math" panose="02040503050406030204" pitchFamily="18" charset="0"/>
+                        </a:rPr>
+                        <m:t>𝑃</m:t>
+                      </m:r>
+                    </m:oMath>
+                  </m:oMathPara>
+                </a14:m>
+                <a:endParaRPr lang="en-US" sz="1600" b="0" dirty="0"/>
+              </a:p>
+            </p:txBody>
+          </p:sp>
+        </mc:Choice>
+        <mc:Fallback xmlns="">
+          <p:sp>
+            <p:nvSpPr>
+              <p:cNvPr id="91" name="TextBox 90">
+                <a:extLst>
+                  <a:ext uri="{FF2B5EF4-FFF2-40B4-BE49-F238E27FC236}">
+                    <a16:creationId xmlns:a16="http://schemas.microsoft.com/office/drawing/2014/main" id="{13ADCA3B-7E51-A633-1C93-C3D05BC4C7C0}"/>
+                  </a:ext>
+                </a:extLst>
+              </p:cNvPr>
+              <p:cNvSpPr txBox="1">
+                <a:spLocks noRot="1" noChangeAspect="1" noMove="1" noResize="1" noEditPoints="1" noAdjustHandles="1" noChangeArrowheads="1" noChangeShapeType="1" noTextEdit="1"/>
+              </p:cNvSpPr>
+              <p:nvPr/>
+            </p:nvSpPr>
+            <p:spPr>
+              <a:xfrm>
+                <a:off x="1566753" y="1897792"/>
+                <a:ext cx="502681" cy="338554"/>
+              </a:xfrm>
+              <a:prstGeom prst="rect">
+                <a:avLst/>
+              </a:prstGeom>
+              <a:blipFill>
+                <a:blip r:embed="rId20"/>
+                <a:stretch>
+                  <a:fillRect/>
+                </a:stretch>
+              </a:blipFill>
+            </p:spPr>
+            <p:txBody>
+              <a:bodyPr/>
+              <a:lstStyle/>
+              <a:p>
+                <a:r>
+                  <a:rPr lang="en-US">
+                    <a:noFill/>
+                  </a:rPr>
+                  <a:t> </a:t>
+                </a:r>
+              </a:p>
+            </p:txBody>
+          </p:sp>
+        </mc:Fallback>
+      </mc:AlternateContent>
+      <p:sp>
+        <p:nvSpPr>
+          <p:cNvPr id="92" name="TextBox 91">
+            <a:extLst>
+              <a:ext uri="{FF2B5EF4-FFF2-40B4-BE49-F238E27FC236}">
+                <a16:creationId xmlns:a16="http://schemas.microsoft.com/office/drawing/2014/main" id="{186888CD-F066-C338-B04F-914425965DF0}"/>
+              </a:ext>
+            </a:extLst>
+          </p:cNvPr>
+          <p:cNvSpPr txBox="1"/>
+          <p:nvPr/>
+        </p:nvSpPr>
+        <p:spPr>
+          <a:xfrm>
+            <a:off x="5042157" y="3954429"/>
+            <a:ext cx="2870368" cy="646331"/>
+          </a:xfrm>
+          <a:prstGeom prst="rect">
+            <a:avLst/>
+          </a:prstGeom>
+          <a:noFill/>
+        </p:spPr>
+        <p:txBody>
+          <a:bodyPr wrap="square" rtlCol="0">
+            <a:spAutoFit/>
+          </a:bodyPr>
+          <a:lstStyle/>
+          <a:p>
+            <a:r>
+              <a:rPr lang="en-US" dirty="0"/>
+              <a:t>Bouc-Wen moment-rotation spring</a:t>
+            </a:r>
+          </a:p>
+        </p:txBody>
+      </p:sp>
+      <p:sp>
+        <p:nvSpPr>
+          <p:cNvPr id="93" name="TextBox 92">
+            <a:extLst>
+              <a:ext uri="{FF2B5EF4-FFF2-40B4-BE49-F238E27FC236}">
+                <a16:creationId xmlns:a16="http://schemas.microsoft.com/office/drawing/2014/main" id="{47F38BD8-F580-DFFE-0263-8C0D42C617AA}"/>
+              </a:ext>
+            </a:extLst>
+          </p:cNvPr>
+          <p:cNvSpPr txBox="1"/>
+          <p:nvPr/>
+        </p:nvSpPr>
+        <p:spPr>
+          <a:xfrm>
+            <a:off x="5042157" y="2738022"/>
+            <a:ext cx="2870368" cy="369332"/>
+          </a:xfrm>
+          <a:prstGeom prst="rect">
+            <a:avLst/>
+          </a:prstGeom>
+          <a:noFill/>
+        </p:spPr>
+        <p:txBody>
+          <a:bodyPr wrap="square" rtlCol="0">
+            <a:spAutoFit/>
+          </a:bodyPr>
+          <a:lstStyle/>
+          <a:p>
+            <a:r>
+              <a:rPr lang="en-US" dirty="0"/>
+              <a:t>Elastic frame element</a:t>
+            </a:r>
+          </a:p>
+        </p:txBody>
+      </p:sp>
+    </p:spTree>
+    <p:extLst>
+      <p:ext uri="{BB962C8B-B14F-4D97-AF65-F5344CB8AC3E}">
+        <p14:creationId xmlns:p14="http://schemas.microsoft.com/office/powerpoint/2010/main" val="4188162361"/>
+      </p:ext>
+    </p:extLst>
+  </p:cSld>
+  <p:clrMapOvr>
+    <a:masterClrMapping/>
+  </p:clrMapOvr>
+</p:sld>
+</file>
+
+<file path=ppt/slides/slide3.xml><?xml version="1.0" encoding="utf-8"?>
 <p:sld xmlns:a="http://schemas.openxmlformats.org/drawingml/2006/main" xmlns:r="http://schemas.openxmlformats.org/officeDocument/2006/relationships" xmlns:p="http://schemas.openxmlformats.org/presentationml/2006/main">
   <p:cSld>
     <p:spTree>
@@ -6353,7 +8618,7 @@
 </p:sld>
 </file>
 
-<file path=ppt/slides/slide3.xml><?xml version="1.0" encoding="utf-8"?>
+<file path=ppt/slides/slide4.xml><?xml version="1.0" encoding="utf-8"?>
 <p:sld xmlns:a="http://schemas.openxmlformats.org/drawingml/2006/main" xmlns:r="http://schemas.openxmlformats.org/officeDocument/2006/relationships" xmlns:p="http://schemas.openxmlformats.org/presentationml/2006/main">
   <p:cSld>
     <p:spTree>
@@ -6503,7 +8768,7 @@
 </p:sld>
 </file>
 
-<file path=ppt/slides/slide4.xml><?xml version="1.0" encoding="utf-8"?>
+<file path=ppt/slides/slide5.xml><?xml version="1.0" encoding="utf-8"?>
 <p:sld xmlns:a="http://schemas.openxmlformats.org/drawingml/2006/main" xmlns:r="http://schemas.openxmlformats.org/officeDocument/2006/relationships" xmlns:p="http://schemas.openxmlformats.org/presentationml/2006/main">
   <p:cSld>
     <p:spTree>
@@ -6653,7 +8918,7 @@
 </p:sld>
 </file>
 
-<file path=ppt/slides/slide5.xml><?xml version="1.0" encoding="utf-8"?>
+<file path=ppt/slides/slide6.xml><?xml version="1.0" encoding="utf-8"?>
 <p:sld xmlns:a="http://schemas.openxmlformats.org/drawingml/2006/main" xmlns:r="http://schemas.openxmlformats.org/officeDocument/2006/relationships" xmlns:p="http://schemas.openxmlformats.org/presentationml/2006/main">
   <p:cSld>
     <p:spTree>
@@ -6734,6 +8999,96 @@
     <p:extLst>
       <p:ext uri="{BB962C8B-B14F-4D97-AF65-F5344CB8AC3E}">
         <p14:creationId xmlns:p14="http://schemas.microsoft.com/office/powerpoint/2010/main" val="257552361"/>
+      </p:ext>
+    </p:extLst>
+  </p:cSld>
+  <p:clrMapOvr>
+    <a:masterClrMapping/>
+  </p:clrMapOvr>
+</p:sld>
+</file>
+
+<file path=ppt/slides/slide7.xml><?xml version="1.0" encoding="utf-8"?>
+<p:sld xmlns:a="http://schemas.openxmlformats.org/drawingml/2006/main" xmlns:r="http://schemas.openxmlformats.org/officeDocument/2006/relationships" xmlns:p="http://schemas.openxmlformats.org/presentationml/2006/main">
+  <p:cSld>
+    <p:spTree>
+      <p:nvGrpSpPr>
+        <p:cNvPr id="1" name=""/>
+        <p:cNvGrpSpPr/>
+        <p:nvPr/>
+      </p:nvGrpSpPr>
+      <p:grpSpPr>
+        <a:xfrm>
+          <a:off x="0" y="0"/>
+          <a:ext cx="0" cy="0"/>
+          <a:chOff x="0" y="0"/>
+          <a:chExt cx="0" cy="0"/>
+        </a:xfrm>
+      </p:grpSpPr>
+      <p:pic>
+        <p:nvPicPr>
+          <p:cNvPr id="5" name="Picture 4">
+            <a:extLst>
+              <a:ext uri="{FF2B5EF4-FFF2-40B4-BE49-F238E27FC236}">
+                <a16:creationId xmlns:a16="http://schemas.microsoft.com/office/drawing/2014/main" id="{40AE518C-EAD8-EB93-5315-82A99AA3DEAE}"/>
+              </a:ext>
+            </a:extLst>
+          </p:cNvPr>
+          <p:cNvPicPr>
+            <a:picLocks noChangeAspect="1"/>
+          </p:cNvPicPr>
+          <p:nvPr/>
+        </p:nvPicPr>
+        <p:blipFill>
+          <a:blip r:embed="rId2"/>
+          <a:stretch>
+            <a:fillRect/>
+          </a:stretch>
+        </p:blipFill>
+        <p:spPr>
+          <a:xfrm>
+            <a:off x="122494" y="1570293"/>
+            <a:ext cx="4449506" cy="3566959"/>
+          </a:xfrm>
+          <a:prstGeom prst="rect">
+            <a:avLst/>
+          </a:prstGeom>
+        </p:spPr>
+      </p:pic>
+      <p:pic>
+        <p:nvPicPr>
+          <p:cNvPr id="9" name="Picture 8">
+            <a:extLst>
+              <a:ext uri="{FF2B5EF4-FFF2-40B4-BE49-F238E27FC236}">
+                <a16:creationId xmlns:a16="http://schemas.microsoft.com/office/drawing/2014/main" id="{928CE106-1878-CA56-7E93-47F6544E2B4D}"/>
+              </a:ext>
+            </a:extLst>
+          </p:cNvPr>
+          <p:cNvPicPr>
+            <a:picLocks noChangeAspect="1"/>
+          </p:cNvPicPr>
+          <p:nvPr/>
+        </p:nvPicPr>
+        <p:blipFill>
+          <a:blip r:embed="rId3"/>
+          <a:stretch>
+            <a:fillRect/>
+          </a:stretch>
+        </p:blipFill>
+        <p:spPr>
+          <a:xfrm>
+            <a:off x="4660695" y="1825113"/>
+            <a:ext cx="3111500" cy="2514600"/>
+          </a:xfrm>
+          <a:prstGeom prst="rect">
+            <a:avLst/>
+          </a:prstGeom>
+        </p:spPr>
+      </p:pic>
+    </p:spTree>
+    <p:extLst>
+      <p:ext uri="{BB962C8B-B14F-4D97-AF65-F5344CB8AC3E}">
+        <p14:creationId xmlns:p14="http://schemas.microsoft.com/office/powerpoint/2010/main" val="69533578"/>
       </p:ext>
     </p:extLst>
   </p:cSld>

</xml_diff>